<commit_message>
Sesion 2026-07-18 (cierre): PDF y PPT actualizados con Kelly y Edge finales
- Agrega seccion/slide de Edge (valor esperado por segmento x precio) a
  ambos reportes, con el hallazgo de heterogeneidad real por tercil de precio
- Actualiza Kelly con la validacion real de Practice contra el campeon
  vigente (scale083): Kelly casi empata (-0.15pp), Edge queda por debajo
  (-1.71pp)
- Confirma round8_distress_fix_scale083 como modelo final de la presentacion
  en ambos documentos
</commit_message>
<xml_diff>
--- a/reports/resumen_proyecto_SAM.pptx
+++ b/reports/resumen_proyecto_SAM.pptx
@@ -14,6 +14,7 @@
     <p:sldId id="262" r:id="rId13"/>
     <p:sldId id="263" r:id="rId14"/>
     <p:sldId id="264" r:id="rId15"/>
+    <p:sldId id="265" r:id="rId16"/>
   </p:sldIdLst>
   <p:sldSz cx="12192000" cy="6858000" type="screen4x3"/>
   <p:notesSz cx="6858000" cy="9144000"/>
@@ -3412,6 +3413,81 @@
 </p:sld>
 </file>
 
+<file path=ppt/slides/slide10.xml><?xml version="1.0" encoding="utf-8"?>
+<p:sld xmlns:a="http://schemas.openxmlformats.org/drawingml/2006/main" xmlns:p="http://schemas.openxmlformats.org/presentationml/2006/main" xmlns:r="http://schemas.openxmlformats.org/officeDocument/2006/relationships">
+  <p:cSld>
+    <p:spTree>
+      <p:nvGrpSpPr>
+        <p:cNvPr id="1" name=""/>
+        <p:cNvGrpSpPr/>
+        <p:nvPr/>
+      </p:nvGrpSpPr>
+      <p:grpSpPr/>
+      <p:pic>
+        <p:nvPicPr>
+          <p:cNvPr id="2" name="Picture 1" descr="austral_closing_bg.jpg"/>
+          <p:cNvPicPr>
+            <a:picLocks noChangeAspect="1"/>
+          </p:cNvPicPr>
+          <p:nvPr/>
+        </p:nvPicPr>
+        <p:blipFill>
+          <a:blip r:embed="rId2"/>
+          <a:stretch>
+            <a:fillRect/>
+          </a:stretch>
+        </p:blipFill>
+        <p:spPr>
+          <a:xfrm>
+            <a:off x="0" y="0"/>
+            <a:ext cx="12192000" cy="6858000"/>
+          </a:xfrm>
+          <a:prstGeom prst="rect">
+            <a:avLst/>
+          </a:prstGeom>
+        </p:spPr>
+      </p:pic>
+      <p:sp>
+        <p:nvSpPr>
+          <p:cNvPr id="3" name="TextBox 2"/>
+          <p:cNvSpPr txBox="1"/>
+          <p:nvPr/>
+        </p:nvSpPr>
+        <p:spPr>
+          <a:xfrm>
+            <a:off x="700000" y="3000000"/>
+            <a:ext cx="6000000" cy="900000"/>
+          </a:xfrm>
+          <a:prstGeom prst="rect">
+            <a:avLst/>
+          </a:prstGeom>
+          <a:noFill/>
+        </p:spPr>
+        <p:txBody>
+          <a:bodyPr wrap="none">
+            <a:spAutoFit/>
+          </a:bodyPr>
+          <a:lstStyle/>
+          <a:p>
+            <a:r>
+              <a:rPr sz="3600" b="1">
+                <a:solidFill>
+                  <a:srgbClr val="1C3087"/>
+                </a:solidFill>
+              </a:rPr>
+              <a:t>MUCHAS GRACIAS</a:t>
+            </a:r>
+          </a:p>
+        </p:txBody>
+      </p:sp>
+    </p:spTree>
+  </p:cSld>
+  <p:clrMapOvr>
+    <a:masterClrMapping/>
+  </p:clrMapOvr>
+</p:sld>
+</file>
+
 <file path=ppt/slides/slide2.xml><?xml version="1.0" encoding="utf-8"?>
 <p:sld xmlns:a="http://schemas.openxmlformats.org/drawingml/2006/main" xmlns:p="http://schemas.openxmlformats.org/presentationml/2006/main" xmlns:r="http://schemas.openxmlformats.org/officeDocument/2006/relationships">
   <p:cSld>
@@ -3885,7 +3961,7 @@
         </p:nvGraphicFramePr>
         <p:xfrm>
           <a:off x="700000" y="1500000"/>
-          <a:ext cx="10800000" cy="5180000"/>
+          <a:ext cx="10800000" cy="5250000"/>
         </p:xfrm>
         <a:graphic>
           <a:graphicData uri="http://schemas.openxmlformats.org/drawingml/2006/table">
@@ -3898,7 +3974,7 @@
                 <a:gridCol w="7600000"/>
                 <a:gridCol w="1600000"/>
               </a:tblGrid>
-              <a:tr h="370000">
+              <a:tr h="350000">
                 <a:tc>
                   <a:txBody>
                     <a:bodyPr wrap="square"/>
@@ -3969,7 +4045,7 @@
                   </a:tcPr>
                 </a:tc>
               </a:tr>
-              <a:tr h="370000">
+              <a:tr h="350000">
                 <a:tc>
                   <a:txBody>
                     <a:bodyPr wrap="square"/>
@@ -4040,7 +4116,7 @@
                   </a:tcPr>
                 </a:tc>
               </a:tr>
-              <a:tr h="370000">
+              <a:tr h="350000">
                 <a:tc>
                   <a:txBody>
                     <a:bodyPr wrap="square"/>
@@ -4111,7 +4187,7 @@
                   </a:tcPr>
                 </a:tc>
               </a:tr>
-              <a:tr h="370000">
+              <a:tr h="350000">
                 <a:tc>
                   <a:txBody>
                     <a:bodyPr wrap="square"/>
@@ -4182,7 +4258,7 @@
                   </a:tcPr>
                 </a:tc>
               </a:tr>
-              <a:tr h="370000">
+              <a:tr h="350000">
                 <a:tc>
                   <a:txBody>
                     <a:bodyPr wrap="square"/>
@@ -4253,7 +4329,7 @@
                   </a:tcPr>
                 </a:tc>
               </a:tr>
-              <a:tr h="370000">
+              <a:tr h="350000">
                 <a:tc>
                   <a:txBody>
                     <a:bodyPr wrap="square"/>
@@ -4324,7 +4400,7 @@
                   </a:tcPr>
                 </a:tc>
               </a:tr>
-              <a:tr h="370000">
+              <a:tr h="350000">
                 <a:tc>
                   <a:txBody>
                     <a:bodyPr wrap="square"/>
@@ -4395,7 +4471,7 @@
                   </a:tcPr>
                 </a:tc>
               </a:tr>
-              <a:tr h="370000">
+              <a:tr h="350000">
                 <a:tc>
                   <a:txBody>
                     <a:bodyPr wrap="square"/>
@@ -4466,7 +4542,7 @@
                   </a:tcPr>
                 </a:tc>
               </a:tr>
-              <a:tr h="370000">
+              <a:tr h="350000">
                 <a:tc>
                   <a:txBody>
                     <a:bodyPr wrap="square"/>
@@ -4537,7 +4613,7 @@
                   </a:tcPr>
                 </a:tc>
               </a:tr>
-              <a:tr h="370000">
+              <a:tr h="350000">
                 <a:tc>
                   <a:txBody>
                     <a:bodyPr wrap="square"/>
@@ -4608,7 +4684,7 @@
                   </a:tcPr>
                 </a:tc>
               </a:tr>
-              <a:tr h="370000">
+              <a:tr h="350000">
                 <a:tc>
                   <a:txBody>
                     <a:bodyPr wrap="square"/>
@@ -4679,7 +4755,7 @@
                   </a:tcPr>
                 </a:tc>
               </a:tr>
-              <a:tr h="370000">
+              <a:tr h="350000">
                 <a:tc>
                   <a:txBody>
                     <a:bodyPr wrap="square"/>
@@ -4750,7 +4826,7 @@
                   </a:tcPr>
                 </a:tc>
               </a:tr>
-              <a:tr h="370000">
+              <a:tr h="350000">
                 <a:tc>
                   <a:txBody>
                     <a:bodyPr wrap="square"/>
@@ -4821,7 +4897,7 @@
                   </a:tcPr>
                 </a:tc>
               </a:tr>
-              <a:tr h="370000">
+              <a:tr h="350000">
                 <a:tc>
                   <a:txBody>
                     <a:bodyPr wrap="square"/>
@@ -4858,7 +4934,7 @@
                           </a:solidFill>
                           <a:latin typeface="Calibri"/>
                         </a:rPr>
-                        <a:t>Criterio de Kelly (escala por segmento)</a:t>
+                        <a:t>Criterio de Kelly (escala por segmento) — casi empata al campeon</a:t>
                       </a:r>
                     </a:p>
                   </a:txBody>
@@ -4888,6 +4964,77 @@
                   <a:tcPr marL="90000" marR="90000" marT="18000" marB="18000">
                     <a:solidFill>
                       <a:srgbClr val="FFFFFF"/>
+                    </a:solidFill>
+                  </a:tcPr>
+                </a:tc>
+              </a:tr>
+              <a:tr h="350000">
+                <a:tc>
+                  <a:txBody>
+                    <a:bodyPr wrap="square"/>
+                    <a:lstStyle/>
+                    <a:p>
+                      <a:pPr algn="l"/>
+                      <a:r>
+                        <a:rPr sz="1000" b="0">
+                          <a:solidFill>
+                            <a:srgbClr val="5B5B5B"/>
+                          </a:solidFill>
+                          <a:latin typeface="Calibri"/>
+                        </a:rPr>
+                        <a:t>Extra</a:t>
+                      </a:r>
+                    </a:p>
+                  </a:txBody>
+                  <a:tcPr marL="90000" marR="90000" marT="18000" marB="18000">
+                    <a:solidFill>
+                      <a:srgbClr val="F7F8FC"/>
+                    </a:solidFill>
+                  </a:tcPr>
+                </a:tc>
+                <a:tc>
+                  <a:txBody>
+                    <a:bodyPr wrap="square"/>
+                    <a:lstStyle/>
+                    <a:p>
+                      <a:pPr algn="l"/>
+                      <a:r>
+                        <a:rPr sz="1050" b="0">
+                          <a:solidFill>
+                            <a:srgbClr val="222222"/>
+                          </a:solidFill>
+                          <a:latin typeface="Calibri"/>
+                        </a:rPr>
+                        <a:t>Edge por bucket (segmento x precio) — no supera al campeon</a:t>
+                      </a:r>
+                    </a:p>
+                  </a:txBody>
+                  <a:tcPr marL="90000" marR="90000" marT="18000" marB="18000">
+                    <a:solidFill>
+                      <a:srgbClr val="F7F8FC"/>
+                    </a:solidFill>
+                  </a:tcPr>
+                </a:tc>
+                <a:tc>
+                  <a:txBody>
+                    <a:bodyPr wrap="square"/>
+                    <a:lstStyle/>
+                    <a:p>
+                      <a:pPr algn="ctr"/>
+                      <a:r>
+                        <a:rPr sz="950" b="1">
+                          <a:solidFill>
+                            <a:srgbClr val="C68136"/>
+                          </a:solidFill>
+                          <a:latin typeface="Calibri"/>
+                        </a:rPr>
+                        <a:t>MIXTO</a:t>
+                      </a:r>
+                    </a:p>
+                  </a:txBody>
+                  <a:tcPr marL="90000" marR="90000" marT="18000" marB="18000">
+                    <a:solidFill>
+                      <a:srgbClr val="F7F8FC"/>
                     </a:solidFill>
                   </a:tcPr>
                 </a:tc>
@@ -6300,7 +6447,7 @@
                   <a:srgbClr val="1C9C82"/>
                 </a:solidFill>
               </a:rPr>
-              <a:t>Mean ROI local: 0.83 plano = 9.95%  →  Kelly por segmento = 10.15%  (mejora chica pero real)</a:t>
+              <a:t>Local: 0.83 plano = 9.95%  →  Kelly = 10.15%  ·  Practice real: Kelly 32.57% vs campeon 32.72% (empate practico)</a:t>
             </a:r>
           </a:p>
         </p:txBody>
@@ -6380,7 +6527,7 @@
             <a:avLst/>
           </a:prstGeom>
           <a:solidFill>
-            <a:srgbClr val="DB5B7D"/>
+            <a:srgbClr val="1C9C82"/>
           </a:solidFill>
           <a:ln>
             <a:noFill/>
@@ -6462,7 +6609,7 @@
                 </a:solidFill>
                 <a:latin typeface="Calibri"/>
               </a:rPr>
-              <a:t>RECOMENDACION FINAL</a:t>
+              <a:t>EXPERIMENTO NUEVO</a:t>
             </a:r>
           </a:p>
         </p:txBody>
@@ -6496,20 +6643,466 @@
                 </a:solidFill>
                 <a:latin typeface="Calibri"/>
               </a:rPr>
-              <a:t>Modelo elegido para la proxima ronda</a:t>
-            </a:r>
-          </a:p>
-        </p:txBody>
-      </p:sp>
-      <p:sp>
-        <p:nvSpPr>
-          <p:cNvPr id="6" name="Rounded Rectangle 5"/>
+              <a:t>Edge (valor esperado) por segmento x precio</a:t>
+            </a:r>
+          </a:p>
+        </p:txBody>
+      </p:sp>
+      <p:sp>
+        <p:nvSpPr>
+          <p:cNvPr id="6" name="TextBox 5"/>
+          <p:cNvSpPr txBox="1"/>
+          <p:nvPr/>
+        </p:nvSpPr>
+        <p:spPr>
+          <a:xfrm>
+            <a:off x="700000" y="1550000"/>
+            <a:ext cx="10800000" cy="1000000"/>
+          </a:xfrm>
+          <a:prstGeom prst="rect">
+            <a:avLst/>
+          </a:prstGeom>
+          <a:noFill/>
+        </p:spPr>
+        <p:txBody>
+          <a:bodyPr wrap="square">
+            <a:spAutoFit/>
+          </a:bodyPr>
+          <a:lstStyle/>
+          <a:p>
+            <a:pPr>
+              <a:lnSpc>
+                <a:spcPct val="120000"/>
+              </a:lnSpc>
+              <a:spcAft>
+                <a:spcPts val="1200"/>
+              </a:spcAft>
+            </a:pPr>
+            <a:r>
+              <a:rPr sz="1500">
+                <a:solidFill>
+                  <a:srgbClr val="222222"/>
+                </a:solidFill>
+                <a:latin typeface="Calibri"/>
+              </a:rPr>
+              <a:t>EV = P(ganar) x (valor_real − costo pagado). Kelly ya midio esto por segmento y no encontro diferencia. Cortando mas fino — segmento x tercil de precio predicho — SI aparece un patron real y consistente.</a:t>
+            </a:r>
+          </a:p>
+        </p:txBody>
+      </p:sp>
+      <p:graphicFrame>
+        <p:nvGraphicFramePr>
+          <p:cNvPr id="7" name="Table 6"/>
+          <p:cNvGraphicFramePr>
+            <a:graphicFrameLocks noGrp="1"/>
+          </p:cNvGraphicFramePr>
+          <p:nvPr/>
+        </p:nvGraphicFramePr>
+        <p:xfrm>
+          <a:off x="1600000" y="2650000"/>
+          <a:ext cx="9000000" cy="1500000"/>
+        </p:xfrm>
+        <a:graphic>
+          <a:graphicData uri="http://schemas.openxmlformats.org/drawingml/2006/table">
+            <a:tbl>
+              <a:tblPr firstRow="1" bandRow="1">
+                <a:tableStyleId>{5C22544A-7EE6-4342-B048-85BDC9FD1C3A}</a:tableStyleId>
+              </a:tblPr>
+              <a:tblGrid>
+                <a:gridCol w="2250000"/>
+                <a:gridCol w="2250000"/>
+                <a:gridCol w="2250000"/>
+                <a:gridCol w="2250000"/>
+              </a:tblGrid>
+              <a:tr h="375000">
+                <a:tc>
+                  <a:txBody>
+                    <a:bodyPr wrap="square"/>
+                    <a:lstStyle/>
+                    <a:p>
+                      <a:pPr algn="ctr"/>
+                      <a:r>
+                        <a:rPr sz="1200" b="1">
+                          <a:solidFill>
+                            <a:srgbClr val="FFFFFF"/>
+                          </a:solidFill>
+                          <a:latin typeface="Calibri"/>
+                        </a:rPr>
+                        <a:t>Bucket</a:t>
+                      </a:r>
+                    </a:p>
+                  </a:txBody>
+                  <a:tcPr marL="90000" marR="90000" marT="18000" marB="18000">
+                    <a:solidFill>
+                      <a:srgbClr val="1C3087"/>
+                    </a:solidFill>
+                  </a:tcPr>
+                </a:tc>
+                <a:tc>
+                  <a:txBody>
+                    <a:bodyPr wrap="square"/>
+                    <a:lstStyle/>
+                    <a:p>
+                      <a:pPr algn="ctr"/>
+                      <a:r>
+                        <a:rPr sz="1200" b="1">
+                          <a:solidFill>
+                            <a:srgbClr val="FFFFFF"/>
+                          </a:solidFill>
+                          <a:latin typeface="Calibri"/>
+                        </a:rPr>
+                        <a:t>Hit Rate</a:t>
+                      </a:r>
+                    </a:p>
+                  </a:txBody>
+                  <a:tcPr marL="90000" marR="90000" marT="18000" marB="18000">
+                    <a:solidFill>
+                      <a:srgbClr val="1C3087"/>
+                    </a:solidFill>
+                  </a:tcPr>
+                </a:tc>
+                <a:tc>
+                  <a:txBody>
+                    <a:bodyPr wrap="square"/>
+                    <a:lstStyle/>
+                    <a:p>
+                      <a:pPr algn="ctr"/>
+                      <a:r>
+                        <a:rPr sz="1200" b="1">
+                          <a:solidFill>
+                            <a:srgbClr val="FFFFFF"/>
+                          </a:solidFill>
+                          <a:latin typeface="Calibri"/>
+                        </a:rPr>
+                        <a:t>EV (% del bid)</a:t>
+                      </a:r>
+                    </a:p>
+                  </a:txBody>
+                  <a:tcPr marL="90000" marR="90000" marT="18000" marB="18000">
+                    <a:solidFill>
+                      <a:srgbClr val="1C3087"/>
+                    </a:solidFill>
+                  </a:tcPr>
+                </a:tc>
+                <a:tc>
+                  <a:txBody>
+                    <a:bodyPr wrap="square"/>
+                    <a:lstStyle/>
+                    <a:p>
+                      <a:pPr algn="ctr"/>
+                      <a:r>
+                        <a:rPr sz="1200" b="1">
+                          <a:solidFill>
+                            <a:srgbClr val="FFFFFF"/>
+                          </a:solidFill>
+                          <a:latin typeface="Calibri"/>
+                        </a:rPr>
+                        <a:t>Escala</a:t>
+                      </a:r>
+                    </a:p>
+                  </a:txBody>
+                  <a:tcPr marL="90000" marR="90000" marT="18000" marB="18000">
+                    <a:solidFill>
+                      <a:srgbClr val="1C3087"/>
+                    </a:solidFill>
+                  </a:tcPr>
+                </a:tc>
+              </a:tr>
+              <a:tr h="375000">
+                <a:tc>
+                  <a:txBody>
+                    <a:bodyPr wrap="square"/>
+                    <a:lstStyle/>
+                    <a:p>
+                      <a:pPr algn="ctr"/>
+                      <a:r>
+                        <a:rPr sz="1100" b="0">
+                          <a:solidFill>
+                            <a:srgbClr val="222222"/>
+                          </a:solidFill>
+                          <a:latin typeface="Calibri"/>
+                        </a:rPr>
+                        <a:t>bajo (los 3 segmentos)</a:t>
+                      </a:r>
+                    </a:p>
+                  </a:txBody>
+                  <a:tcPr marL="90000" marR="90000" marT="18000" marB="18000">
+                    <a:solidFill>
+                      <a:srgbClr val="FFFFFF"/>
+                    </a:solidFill>
+                  </a:tcPr>
+                </a:tc>
+                <a:tc>
+                  <a:txBody>
+                    <a:bodyPr wrap="square"/>
+                    <a:lstStyle/>
+                    <a:p>
+                      <a:pPr algn="ctr"/>
+                      <a:r>
+                        <a:rPr sz="1100" b="0">
+                          <a:solidFill>
+                            <a:srgbClr val="222222"/>
+                          </a:solidFill>
+                          <a:latin typeface="Calibri"/>
+                        </a:rPr>
+                        <a:t>77.2%</a:t>
+                      </a:r>
+                    </a:p>
+                  </a:txBody>
+                  <a:tcPr marL="90000" marR="90000" marT="18000" marB="18000">
+                    <a:solidFill>
+                      <a:srgbClr val="FFFFFF"/>
+                    </a:solidFill>
+                  </a:tcPr>
+                </a:tc>
+                <a:tc>
+                  <a:txBody>
+                    <a:bodyPr wrap="square"/>
+                    <a:lstStyle/>
+                    <a:p>
+                      <a:pPr algn="ctr"/>
+                      <a:r>
+                        <a:rPr sz="1100" b="0">
+                          <a:solidFill>
+                            <a:srgbClr val="222222"/>
+                          </a:solidFill>
+                          <a:latin typeface="Calibri"/>
+                        </a:rPr>
+                        <a:t>1.51%</a:t>
+                      </a:r>
+                    </a:p>
+                  </a:txBody>
+                  <a:tcPr marL="90000" marR="90000" marT="18000" marB="18000">
+                    <a:solidFill>
+                      <a:srgbClr val="FFFFFF"/>
+                    </a:solidFill>
+                  </a:tcPr>
+                </a:tc>
+                <a:tc>
+                  <a:txBody>
+                    <a:bodyPr wrap="square"/>
+                    <a:lstStyle/>
+                    <a:p>
+                      <a:pPr algn="ctr"/>
+                      <a:r>
+                        <a:rPr sz="1100" b="0">
+                          <a:solidFill>
+                            <a:srgbClr val="222222"/>
+                          </a:solidFill>
+                          <a:latin typeface="Calibri"/>
+                        </a:rPr>
+                        <a:t>~0.80</a:t>
+                      </a:r>
+                    </a:p>
+                  </a:txBody>
+                  <a:tcPr marL="90000" marR="90000" marT="18000" marB="18000">
+                    <a:solidFill>
+                      <a:srgbClr val="FFFFFF"/>
+                    </a:solidFill>
+                  </a:tcPr>
+                </a:tc>
+              </a:tr>
+              <a:tr h="375000">
+                <a:tc>
+                  <a:txBody>
+                    <a:bodyPr wrap="square"/>
+                    <a:lstStyle/>
+                    <a:p>
+                      <a:pPr algn="ctr"/>
+                      <a:r>
+                        <a:rPr sz="1100" b="0">
+                          <a:solidFill>
+                            <a:srgbClr val="222222"/>
+                          </a:solidFill>
+                          <a:latin typeface="Calibri"/>
+                        </a:rPr>
+                        <a:t>medio (los 3 segmentos)</a:t>
+                      </a:r>
+                    </a:p>
+                  </a:txBody>
+                  <a:tcPr marL="90000" marR="90000" marT="18000" marB="18000">
+                    <a:solidFill>
+                      <a:srgbClr val="F7F8FC"/>
+                    </a:solidFill>
+                  </a:tcPr>
+                </a:tc>
+                <a:tc>
+                  <a:txBody>
+                    <a:bodyPr wrap="square"/>
+                    <a:lstStyle/>
+                    <a:p>
+                      <a:pPr algn="ctr"/>
+                      <a:r>
+                        <a:rPr sz="1100" b="0">
+                          <a:solidFill>
+                            <a:srgbClr val="222222"/>
+                          </a:solidFill>
+                          <a:latin typeface="Calibri"/>
+                        </a:rPr>
+                        <a:t>86.1%</a:t>
+                      </a:r>
+                    </a:p>
+                  </a:txBody>
+                  <a:tcPr marL="90000" marR="90000" marT="18000" marB="18000">
+                    <a:solidFill>
+                      <a:srgbClr val="F7F8FC"/>
+                    </a:solidFill>
+                  </a:tcPr>
+                </a:tc>
+                <a:tc>
+                  <a:txBody>
+                    <a:bodyPr wrap="square"/>
+                    <a:lstStyle/>
+                    <a:p>
+                      <a:pPr algn="ctr"/>
+                      <a:r>
+                        <a:rPr sz="1100" b="0">
+                          <a:solidFill>
+                            <a:srgbClr val="222222"/>
+                          </a:solidFill>
+                          <a:latin typeface="Calibri"/>
+                        </a:rPr>
+                        <a:t>1.75%</a:t>
+                      </a:r>
+                    </a:p>
+                  </a:txBody>
+                  <a:tcPr marL="90000" marR="90000" marT="18000" marB="18000">
+                    <a:solidFill>
+                      <a:srgbClr val="F7F8FC"/>
+                    </a:solidFill>
+                  </a:tcPr>
+                </a:tc>
+                <a:tc>
+                  <a:txBody>
+                    <a:bodyPr wrap="square"/>
+                    <a:lstStyle/>
+                    <a:p>
+                      <a:pPr algn="ctr"/>
+                      <a:r>
+                        <a:rPr sz="1100" b="0">
+                          <a:solidFill>
+                            <a:srgbClr val="222222"/>
+                          </a:solidFill>
+                          <a:latin typeface="Calibri"/>
+                        </a:rPr>
+                        <a:t>~0.83</a:t>
+                      </a:r>
+                    </a:p>
+                  </a:txBody>
+                  <a:tcPr marL="90000" marR="90000" marT="18000" marB="18000">
+                    <a:solidFill>
+                      <a:srgbClr val="F7F8FC"/>
+                    </a:solidFill>
+                  </a:tcPr>
+                </a:tc>
+              </a:tr>
+              <a:tr h="375000">
+                <a:tc>
+                  <a:txBody>
+                    <a:bodyPr wrap="square"/>
+                    <a:lstStyle/>
+                    <a:p>
+                      <a:pPr algn="ctr"/>
+                      <a:r>
+                        <a:rPr sz="1100" b="0">
+                          <a:solidFill>
+                            <a:srgbClr val="222222"/>
+                          </a:solidFill>
+                          <a:latin typeface="Calibri"/>
+                        </a:rPr>
+                        <a:t>alto (los 3 segmentos)</a:t>
+                      </a:r>
+                    </a:p>
+                  </a:txBody>
+                  <a:tcPr marL="90000" marR="90000" marT="18000" marB="18000">
+                    <a:solidFill>
+                      <a:srgbClr val="FFFFFF"/>
+                    </a:solidFill>
+                  </a:tcPr>
+                </a:tc>
+                <a:tc>
+                  <a:txBody>
+                    <a:bodyPr wrap="square"/>
+                    <a:lstStyle/>
+                    <a:p>
+                      <a:pPr algn="ctr"/>
+                      <a:r>
+                        <a:rPr sz="1100" b="0">
+                          <a:solidFill>
+                            <a:srgbClr val="222222"/>
+                          </a:solidFill>
+                          <a:latin typeface="Calibri"/>
+                        </a:rPr>
+                        <a:t>91.4%</a:t>
+                      </a:r>
+                    </a:p>
+                  </a:txBody>
+                  <a:tcPr marL="90000" marR="90000" marT="18000" marB="18000">
+                    <a:solidFill>
+                      <a:srgbClr val="FFFFFF"/>
+                    </a:solidFill>
+                  </a:tcPr>
+                </a:tc>
+                <a:tc>
+                  <a:txBody>
+                    <a:bodyPr wrap="square"/>
+                    <a:lstStyle/>
+                    <a:p>
+                      <a:pPr algn="ctr"/>
+                      <a:r>
+                        <a:rPr sz="1100" b="0">
+                          <a:solidFill>
+                            <a:srgbClr val="222222"/>
+                          </a:solidFill>
+                          <a:latin typeface="Calibri"/>
+                        </a:rPr>
+                        <a:t>2.06%</a:t>
+                      </a:r>
+                    </a:p>
+                  </a:txBody>
+                  <a:tcPr marL="90000" marR="90000" marT="18000" marB="18000">
+                    <a:solidFill>
+                      <a:srgbClr val="FFFFFF"/>
+                    </a:solidFill>
+                  </a:tcPr>
+                </a:tc>
+                <a:tc>
+                  <a:txBody>
+                    <a:bodyPr wrap="square"/>
+                    <a:lstStyle/>
+                    <a:p>
+                      <a:pPr algn="ctr"/>
+                      <a:r>
+                        <a:rPr sz="1100" b="0">
+                          <a:solidFill>
+                            <a:srgbClr val="222222"/>
+                          </a:solidFill>
+                          <a:latin typeface="Calibri"/>
+                        </a:rPr>
+                        <a:t>~0.87</a:t>
+                      </a:r>
+                    </a:p>
+                  </a:txBody>
+                  <a:tcPr marL="90000" marR="90000" marT="18000" marB="18000">
+                    <a:solidFill>
+                      <a:srgbClr val="FFFFFF"/>
+                    </a:solidFill>
+                  </a:tcPr>
+                </a:tc>
+              </a:tr>
+            </a:tbl>
+          </a:graphicData>
+        </a:graphic>
+      </p:graphicFrame>
+      <p:sp>
+        <p:nvSpPr>
+          <p:cNvPr id="8" name="Rounded Rectangle 7"/>
           <p:cNvSpPr/>
           <p:nvPr/>
         </p:nvSpPr>
         <p:spPr>
           <a:xfrm>
-            <a:off x="700000" y="1650000"/>
+            <a:off x="700000" y="4550000"/>
             <a:ext cx="10800000" cy="650000"/>
           </a:xfrm>
           <a:prstGeom prst="roundRect">
@@ -6520,7 +7113,7 @@
           </a:solidFill>
           <a:ln w="19050">
             <a:solidFill>
-              <a:srgbClr val="1C3087"/>
+              <a:srgbClr val="C68136"/>
             </a:solidFill>
           </a:ln>
           <a:effectLst/>
@@ -6547,24 +7140,24 @@
             <a:r>
               <a:rPr sz="1400" b="1">
                 <a:solidFill>
-                  <a:srgbClr val="1C3087"/>
+                  <a:srgbClr val="C68136"/>
                 </a:solidFill>
               </a:rPr>
-              <a:t>round8_distress_fix_scale083.csv</a:t>
-            </a:r>
-          </a:p>
-        </p:txBody>
-      </p:sp>
-      <p:sp>
-        <p:nvSpPr>
-          <p:cNvPr id="7" name="TextBox 6"/>
+              <a:t>Local: 0.83 plano = 9.95%  →  Edge = 10.22%  ·  Practice real: Edge 31.01% vs campeon 32.72% (queda por debajo)</a:t>
+            </a:r>
+          </a:p>
+        </p:txBody>
+      </p:sp>
+      <p:sp>
+        <p:nvSpPr>
+          <p:cNvPr id="9" name="TextBox 8"/>
           <p:cNvSpPr txBox="1"/>
           <p:nvPr/>
         </p:nvSpPr>
         <p:spPr>
           <a:xfrm>
-            <a:off x="700000" y="2500000"/>
-            <a:ext cx="10800000" cy="1400000"/>
+            <a:off x="700000" y="5300000"/>
+            <a:ext cx="10800000" cy="900000"/>
           </a:xfrm>
           <a:prstGeom prst="rect">
             <a:avLst/>
@@ -6586,120 +7179,13 @@
               </a:spcAft>
             </a:pPr>
             <a:r>
-              <a:rPr sz="1600">
+              <a:rPr sz="1300">
                 <a:solidFill>
-                  <a:srgbClr val="222222"/>
+                  <a:srgbClr val="5B5B5B"/>
                 </a:solidFill>
                 <a:latin typeface="Calibri"/>
               </a:rPr>
-              <a:t>Es el modelo de Ronda 8 (tabular + imagenes CLIP + fix quirurgico de propiedades distressed confirmadas) con todas las predicciones escaladas x0.83. Es la combinacion que mejor Mean ROI mostro de forma consistente en validaciones repetidas, tanto en simulacion local como en el dashboard real de Practice.</a:t>
-            </a:r>
-          </a:p>
-        </p:txBody>
-      </p:sp>
-      <p:sp>
-        <p:nvSpPr>
-          <p:cNvPr id="8" name="TextBox 7"/>
-          <p:cNvSpPr txBox="1"/>
-          <p:nvPr/>
-        </p:nvSpPr>
-        <p:spPr>
-          <a:xfrm>
-            <a:off x="700000" y="4200000"/>
-            <a:ext cx="10800000" cy="1800000"/>
-          </a:xfrm>
-          <a:prstGeom prst="rect">
-            <a:avLst/>
-          </a:prstGeom>
-          <a:noFill/>
-        </p:spPr>
-        <p:txBody>
-          <a:bodyPr wrap="square">
-            <a:spAutoFit/>
-          </a:bodyPr>
-          <a:lstStyle/>
-          <a:p>
-            <a:pPr>
-              <a:lnSpc>
-                <a:spcPct val="115000"/>
-              </a:lnSpc>
-              <a:spcAft>
-                <a:spcPts val="1400"/>
-              </a:spcAft>
-            </a:pPr>
-            <a:r>
-              <a:rPr sz="1500" b="1">
-                <a:solidFill>
-                  <a:srgbClr val="C68136"/>
-                </a:solidFill>
-                <a:latin typeface="Calibri"/>
-              </a:rPr>
-              <a:t>▸  </a:t>
-            </a:r>
-            <a:r>
-              <a:rPr sz="1500">
-                <a:solidFill>
-                  <a:srgbClr val="222222"/>
-                </a:solidFill>
-                <a:latin typeface="Calibri"/>
-              </a:rPr>
-              <a:t>Rondas 1 a 8: evolucion incremental, validada en Practice en cada paso.</a:t>
-            </a:r>
-          </a:p>
-          <a:p>
-            <a:pPr>
-              <a:lnSpc>
-                <a:spcPct val="115000"/>
-              </a:lnSpc>
-              <a:spcAft>
-                <a:spcPts val="1400"/>
-              </a:spcAft>
-            </a:pPr>
-            <a:r>
-              <a:rPr sz="1500" b="1">
-                <a:solidFill>
-                  <a:srgbClr val="C68136"/>
-                </a:solidFill>
-                <a:latin typeface="Calibri"/>
-              </a:rPr>
-              <a:t>▸  </a:t>
-            </a:r>
-            <a:r>
-              <a:rPr sz="1500">
-                <a:solidFill>
-                  <a:srgbClr val="222222"/>
-                </a:solidFill>
-                <a:latin typeface="Calibri"/>
-              </a:rPr>
-              <a:t>Ronda 9 (texto/LLM): pausada, no aporta con la cobertura/calidad actual.</a:t>
-            </a:r>
-          </a:p>
-          <a:p>
-            <a:pPr>
-              <a:lnSpc>
-                <a:spcPct val="115000"/>
-              </a:lnSpc>
-              <a:spcAft>
-                <a:spcPts val="1400"/>
-              </a:spcAft>
-            </a:pPr>
-            <a:r>
-              <a:rPr sz="1500" b="1">
-                <a:solidFill>
-                  <a:srgbClr val="C68136"/>
-                </a:solidFill>
-                <a:latin typeface="Calibri"/>
-              </a:rPr>
-              <a:t>▸  </a:t>
-            </a:r>
-            <a:r>
-              <a:rPr sz="1500">
-                <a:solidFill>
-                  <a:srgbClr val="222222"/>
-                </a:solidFill>
-                <a:latin typeface="Calibri"/>
-              </a:rPr>
-              <a:t>Calibracion de escala: la mejora final, grande y reproducible.</a:t>
+              <a:t>El tercil 'alto' de precio siempre tiene mas edge que el 'bajo', en los 3 segmentos. Real, pero en Practice la mayor selectividad (menos volumen) no alcanzo para superar al campeon.</a:t>
             </a:r>
           </a:p>
         </p:txBody>
@@ -6722,9 +7208,53 @@
         <p:nvPr/>
       </p:nvGrpSpPr>
       <p:grpSpPr/>
+      <p:sp>
+        <p:nvSpPr>
+          <p:cNvPr id="2" name="Right Triangle 1"/>
+          <p:cNvSpPr/>
+          <p:nvPr/>
+        </p:nvSpPr>
+        <p:spPr>
+          <a:xfrm rot="10800000">
+            <a:off x="9666111" y="-98779"/>
+            <a:ext cx="2596444" cy="2413000"/>
+          </a:xfrm>
+          <a:prstGeom prst="rtTriangle">
+            <a:avLst/>
+          </a:prstGeom>
+          <a:solidFill>
+            <a:srgbClr val="DB5B7D"/>
+          </a:solidFill>
+          <a:ln>
+            <a:noFill/>
+          </a:ln>
+          <a:effectLst/>
+        </p:spPr>
+        <p:style>
+          <a:lnRef idx="1">
+            <a:schemeClr val="accent1"/>
+          </a:lnRef>
+          <a:fillRef idx="3">
+            <a:schemeClr val="accent1"/>
+          </a:fillRef>
+          <a:effectRef idx="2">
+            <a:schemeClr val="accent1"/>
+          </a:effectRef>
+          <a:fontRef idx="minor">
+            <a:schemeClr val="lt1"/>
+          </a:fontRef>
+        </p:style>
+        <p:txBody>
+          <a:bodyPr rtlCol="0" anchor="ctr"/>
+          <a:lstStyle/>
+          <a:p>
+            <a:pPr algn="ctr"/>
+          </a:p>
+        </p:txBody>
+      </p:sp>
       <p:pic>
         <p:nvPicPr>
-          <p:cNvPr id="2" name="Picture 1" descr="austral_closing_bg.jpg"/>
+          <p:cNvPr id="3" name="Picture 2" descr="austral_logo.jpeg"/>
           <p:cNvPicPr>
             <a:picLocks noChangeAspect="1"/>
           </p:cNvPicPr>
@@ -6738,8 +7268,8 @@
         </p:blipFill>
         <p:spPr>
           <a:xfrm>
-            <a:off x="0" y="0"/>
-            <a:ext cx="12192000" cy="6858000"/>
+            <a:off x="300000" y="5550000"/>
+            <a:ext cx="1746504" cy="1170432"/>
           </a:xfrm>
           <a:prstGeom prst="rect">
             <a:avLst/>
@@ -6748,14 +7278,14 @@
       </p:pic>
       <p:sp>
         <p:nvSpPr>
-          <p:cNvPr id="3" name="TextBox 2"/>
+          <p:cNvPr id="4" name="TextBox 3"/>
           <p:cNvSpPr txBox="1"/>
           <p:nvPr/>
         </p:nvSpPr>
         <p:spPr>
           <a:xfrm>
-            <a:off x="700000" y="3000000"/>
-            <a:ext cx="6000000" cy="900000"/>
+            <a:off x="700000" y="200000"/>
+            <a:ext cx="6000000" cy="280000"/>
           </a:xfrm>
           <a:prstGeom prst="rect">
             <a:avLst/>
@@ -6769,12 +7299,250 @@
           <a:lstStyle/>
           <a:p>
             <a:r>
-              <a:rPr sz="3600" b="1">
+              <a:rPr sz="1300" b="1">
+                <a:solidFill>
+                  <a:srgbClr val="C68136"/>
+                </a:solidFill>
+                <a:latin typeface="Calibri"/>
+              </a:rPr>
+              <a:t>RECOMENDACION FINAL</a:t>
+            </a:r>
+          </a:p>
+        </p:txBody>
+      </p:sp>
+      <p:sp>
+        <p:nvSpPr>
+          <p:cNvPr id="5" name="TextBox 4"/>
+          <p:cNvSpPr txBox="1"/>
+          <p:nvPr/>
+        </p:nvSpPr>
+        <p:spPr>
+          <a:xfrm>
+            <a:off x="700000" y="430000"/>
+            <a:ext cx="10800000" cy="650000"/>
+          </a:xfrm>
+          <a:prstGeom prst="rect">
+            <a:avLst/>
+          </a:prstGeom>
+          <a:noFill/>
+        </p:spPr>
+        <p:txBody>
+          <a:bodyPr wrap="square">
+            <a:spAutoFit/>
+          </a:bodyPr>
+          <a:lstStyle/>
+          <a:p>
+            <a:r>
+              <a:rPr sz="3000" b="1">
+                <a:solidFill>
+                  <a:srgbClr val="1C3087"/>
+                </a:solidFill>
+                <a:latin typeface="Calibri"/>
+              </a:rPr>
+              <a:t>Modelo elegido para la presentacion final</a:t>
+            </a:r>
+          </a:p>
+        </p:txBody>
+      </p:sp>
+      <p:sp>
+        <p:nvSpPr>
+          <p:cNvPr id="6" name="Rounded Rectangle 5"/>
+          <p:cNvSpPr/>
+          <p:nvPr/>
+        </p:nvSpPr>
+        <p:spPr>
+          <a:xfrm>
+            <a:off x="700000" y="1650000"/>
+            <a:ext cx="10800000" cy="650000"/>
+          </a:xfrm>
+          <a:prstGeom prst="roundRect">
+            <a:avLst/>
+          </a:prstGeom>
+          <a:solidFill>
+            <a:srgbClr val="FFFFFF"/>
+          </a:solidFill>
+          <a:ln w="19050">
+            <a:solidFill>
+              <a:srgbClr val="1C3087"/>
+            </a:solidFill>
+          </a:ln>
+          <a:effectLst/>
+        </p:spPr>
+        <p:style>
+          <a:lnRef idx="1">
+            <a:schemeClr val="accent1"/>
+          </a:lnRef>
+          <a:fillRef idx="3">
+            <a:schemeClr val="accent1"/>
+          </a:fillRef>
+          <a:effectRef idx="2">
+            <a:schemeClr val="accent1"/>
+          </a:effectRef>
+          <a:fontRef idx="minor">
+            <a:schemeClr val="lt1"/>
+          </a:fontRef>
+        </p:style>
+        <p:txBody>
+          <a:bodyPr rtlCol="0" anchor="ctr" wrap="square" lIns="180000"/>
+          <a:lstStyle/>
+          <a:p>
+            <a:pPr algn="ctr"/>
+            <a:r>
+              <a:rPr sz="1400" b="1">
                 <a:solidFill>
                   <a:srgbClr val="1C3087"/>
                 </a:solidFill>
               </a:rPr>
-              <a:t>MUCHAS GRACIAS</a:t>
+              <a:t>round8_distress_fix_scale083.csv</a:t>
+            </a:r>
+          </a:p>
+        </p:txBody>
+      </p:sp>
+      <p:sp>
+        <p:nvSpPr>
+          <p:cNvPr id="7" name="TextBox 6"/>
+          <p:cNvSpPr txBox="1"/>
+          <p:nvPr/>
+        </p:nvSpPr>
+        <p:spPr>
+          <a:xfrm>
+            <a:off x="700000" y="2500000"/>
+            <a:ext cx="10800000" cy="1600000"/>
+          </a:xfrm>
+          <a:prstGeom prst="rect">
+            <a:avLst/>
+          </a:prstGeom>
+          <a:noFill/>
+        </p:spPr>
+        <p:txBody>
+          <a:bodyPr wrap="square">
+            <a:spAutoFit/>
+          </a:bodyPr>
+          <a:lstStyle/>
+          <a:p>
+            <a:pPr>
+              <a:lnSpc>
+                <a:spcPct val="120000"/>
+              </a:lnSpc>
+              <a:spcAft>
+                <a:spcPts val="1200"/>
+              </a:spcAft>
+            </a:pPr>
+            <a:r>
+              <a:rPr sz="1550">
+                <a:solidFill>
+                  <a:srgbClr val="222222"/>
+                </a:solidFill>
+                <a:latin typeface="Calibri"/>
+              </a:rPr>
+              <a:t>Es el modelo de Ronda 8 (tabular + imagenes CLIP + fix quirurgico de propiedades distressed) con todas las predicciones escaladas x0.83. Se probaron dos refinamientos mas finos para tratar de superarlo (Kelly por segmento y Edge por segmento x precio, secciones 6 y 7): ninguno le gano de forma clara en el dashboard real de Practice. La escala 0.83 queda confirmada como la mejor opcion disponible.</a:t>
+            </a:r>
+          </a:p>
+        </p:txBody>
+      </p:sp>
+      <p:sp>
+        <p:nvSpPr>
+          <p:cNvPr id="8" name="TextBox 7"/>
+          <p:cNvSpPr txBox="1"/>
+          <p:nvPr/>
+        </p:nvSpPr>
+        <p:spPr>
+          <a:xfrm>
+            <a:off x="700000" y="4500000"/>
+            <a:ext cx="10800000" cy="1800000"/>
+          </a:xfrm>
+          <a:prstGeom prst="rect">
+            <a:avLst/>
+          </a:prstGeom>
+          <a:noFill/>
+        </p:spPr>
+        <p:txBody>
+          <a:bodyPr wrap="square">
+            <a:spAutoFit/>
+          </a:bodyPr>
+          <a:lstStyle/>
+          <a:p>
+            <a:pPr>
+              <a:lnSpc>
+                <a:spcPct val="115000"/>
+              </a:lnSpc>
+              <a:spcAft>
+                <a:spcPts val="1400"/>
+              </a:spcAft>
+            </a:pPr>
+            <a:r>
+              <a:rPr sz="1450" b="1">
+                <a:solidFill>
+                  <a:srgbClr val="C68136"/>
+                </a:solidFill>
+                <a:latin typeface="Calibri"/>
+              </a:rPr>
+              <a:t>▸  </a:t>
+            </a:r>
+            <a:r>
+              <a:rPr sz="1450">
+                <a:solidFill>
+                  <a:srgbClr val="222222"/>
+                </a:solidFill>
+                <a:latin typeface="Calibri"/>
+              </a:rPr>
+              <a:t>Rondas 1 a 8: evolucion incremental, validada en Practice en cada paso.</a:t>
+            </a:r>
+          </a:p>
+          <a:p>
+            <a:pPr>
+              <a:lnSpc>
+                <a:spcPct val="115000"/>
+              </a:lnSpc>
+              <a:spcAft>
+                <a:spcPts val="1400"/>
+              </a:spcAft>
+            </a:pPr>
+            <a:r>
+              <a:rPr sz="1450" b="1">
+                <a:solidFill>
+                  <a:srgbClr val="C68136"/>
+                </a:solidFill>
+                <a:latin typeface="Calibri"/>
+              </a:rPr>
+              <a:t>▸  </a:t>
+            </a:r>
+            <a:r>
+              <a:rPr sz="1450">
+                <a:solidFill>
+                  <a:srgbClr val="222222"/>
+                </a:solidFill>
+                <a:latin typeface="Calibri"/>
+              </a:rPr>
+              <a:t>Ronda 9 (texto/LLM): pausada, no aporta con la cobertura/calidad actual.</a:t>
+            </a:r>
+          </a:p>
+          <a:p>
+            <a:pPr>
+              <a:lnSpc>
+                <a:spcPct val="115000"/>
+              </a:lnSpc>
+              <a:spcAft>
+                <a:spcPts val="1400"/>
+              </a:spcAft>
+            </a:pPr>
+            <a:r>
+              <a:rPr sz="1450" b="1">
+                <a:solidFill>
+                  <a:srgbClr val="C68136"/>
+                </a:solidFill>
+                <a:latin typeface="Calibri"/>
+              </a:rPr>
+              <a:t>▸  </a:t>
+            </a:r>
+            <a:r>
+              <a:rPr sz="1450">
+                <a:solidFill>
+                  <a:srgbClr val="222222"/>
+                </a:solidFill>
+                <a:latin typeface="Calibri"/>
+              </a:rPr>
+              <a:t>Kelly y Edge: probados a fondo, ninguno le gano al campeon — se cierra la busqueda de mejoras con la escala 0.83 confirmada.</a:t>
             </a:r>
           </a:p>
         </p:txBody>

</xml_diff>

<commit_message>
Sesion 2026-08-02 (cont.): aclaracion sobre el grafico de escala local
El barrido de escala local muestra un pico en 0.85 levemente mas alto que
0.83, lo cual podia confundir en la defensa. Se agrega una aclaracion en
los 3 documentos (PDF color, PDF imprimible, PPT): esa simulacion casera
es aproximada, y la decision real se tomo con 3 corridas independientes en
el dashboard de Practice, donde 0.83 le gano a 0.85 de forma consistente.

Se guarda tambien reports/desarrollo_proyecto_SAM.pdf (version a color),
pendiente de la sesion anterior por estar el archivo bloqueado.
</commit_message>
<xml_diff>
--- a/reports/resumen_proyecto_SAM.pptx
+++ b/reports/resumen_proyecto_SAM.pptx
@@ -5640,9 +5640,119 @@
           </a:p>
         </p:txBody>
       </p:sp>
+      <p:sp>
+        <p:nvSpPr>
+          <p:cNvPr id="3" name="TextBox 2"/>
+          <p:cNvSpPr txBox="1"/>
+          <p:nvPr/>
+        </p:nvSpPr>
+        <p:spPr>
+          <a:xfrm>
+            <a:off x="700000" y="200000"/>
+            <a:ext cx="6000000" cy="280000"/>
+          </a:xfrm>
+          <a:prstGeom prst="rect">
+            <a:avLst/>
+          </a:prstGeom>
+          <a:noFill/>
+        </p:spPr>
+        <p:txBody>
+          <a:bodyPr wrap="none">
+            <a:spAutoFit/>
+          </a:bodyPr>
+          <a:lstStyle/>
+          <a:p>
+            <a:r>
+              <a:rPr sz="1300" b="1">
+                <a:solidFill>
+                  <a:srgbClr val="C68136"/>
+                </a:solidFill>
+                <a:latin typeface="Calibri"/>
+              </a:rPr>
+              <a:t>LA MEJORA FINAL</a:t>
+            </a:r>
+          </a:p>
+        </p:txBody>
+      </p:sp>
+      <p:sp>
+        <p:nvSpPr>
+          <p:cNvPr id="4" name="TextBox 3"/>
+          <p:cNvSpPr txBox="1"/>
+          <p:nvPr/>
+        </p:nvSpPr>
+        <p:spPr>
+          <a:xfrm>
+            <a:off x="700000" y="430000"/>
+            <a:ext cx="10800000" cy="650000"/>
+          </a:xfrm>
+          <a:prstGeom prst="rect">
+            <a:avLst/>
+          </a:prstGeom>
+          <a:noFill/>
+        </p:spPr>
+        <p:txBody>
+          <a:bodyPr wrap="square">
+            <a:spAutoFit/>
+          </a:bodyPr>
+          <a:lstStyle/>
+          <a:p>
+            <a:r>
+              <a:rPr sz="3000" b="1">
+                <a:solidFill>
+                  <a:srgbClr val="1C3087"/>
+                </a:solidFill>
+                <a:latin typeface="Calibri"/>
+              </a:rPr>
+              <a:t>Calibracion de escala sobre Ronda 8</a:t>
+            </a:r>
+          </a:p>
+        </p:txBody>
+      </p:sp>
+      <p:sp>
+        <p:nvSpPr>
+          <p:cNvPr id="5" name="TextBox 4"/>
+          <p:cNvSpPr txBox="1"/>
+          <p:nvPr/>
+        </p:nvSpPr>
+        <p:spPr>
+          <a:xfrm>
+            <a:off x="700000" y="1150000"/>
+            <a:ext cx="10800000" cy="500000"/>
+          </a:xfrm>
+          <a:prstGeom prst="rect">
+            <a:avLst/>
+          </a:prstGeom>
+          <a:noFill/>
+        </p:spPr>
+        <p:txBody>
+          <a:bodyPr wrap="square">
+            <a:spAutoFit/>
+          </a:bodyPr>
+          <a:lstStyle/>
+          <a:p>
+            <a:pPr>
+              <a:lnSpc>
+                <a:spcPct val="120000"/>
+              </a:lnSpc>
+              <a:spcAft>
+                <a:spcPts val="1200"/>
+              </a:spcAft>
+            </a:pPr>
+            <a:r>
+              <a:rPr sz="1200">
+                <a:solidFill>
+                  <a:srgbClr val="5B5B5B"/>
+                </a:solidFill>
+                <a:latin typeface="Calibri"/>
+              </a:rPr>
+              <a:t>Ojo: en el grafico, 0.85 parece ganarle a 0.83 — pero es una simulacion casera aproximada, no la fuente de verdad (ver por que abajo).</a:t>
+            </a:r>
+          </a:p>
+        </p:txBody>
+      </p:sp>
       <p:pic>
         <p:nvPicPr>
-          <p:cNvPr id="3" name="Picture 2" descr="austral_logo.jpeg"/>
+          <p:cNvPr id="6" name="Picture 5" descr="chart_scale_sweep.png"/>
           <p:cNvPicPr>
             <a:picLocks noChangeAspect="1"/>
           </p:cNvPicPr>
@@ -5656,8 +5766,8 @@
         </p:blipFill>
         <p:spPr>
           <a:xfrm>
-            <a:off x="300000" y="5550000"/>
-            <a:ext cx="1746504" cy="1170432"/>
+            <a:off x="1700000" y="1650000"/>
+            <a:ext cx="8800000" cy="4261053"/>
           </a:xfrm>
           <a:prstGeom prst="rect">
             <a:avLst/>
@@ -5666,106 +5776,14 @@
       </p:pic>
       <p:sp>
         <p:nvSpPr>
-          <p:cNvPr id="4" name="TextBox 3"/>
-          <p:cNvSpPr txBox="1"/>
-          <p:nvPr/>
-        </p:nvSpPr>
-        <p:spPr>
-          <a:xfrm>
-            <a:off x="700000" y="200000"/>
-            <a:ext cx="6000000" cy="280000"/>
-          </a:xfrm>
-          <a:prstGeom prst="rect">
-            <a:avLst/>
-          </a:prstGeom>
-          <a:noFill/>
-        </p:spPr>
-        <p:txBody>
-          <a:bodyPr wrap="none">
-            <a:spAutoFit/>
-          </a:bodyPr>
-          <a:lstStyle/>
-          <a:p>
-            <a:r>
-              <a:rPr sz="1300" b="1">
-                <a:solidFill>
-                  <a:srgbClr val="C68136"/>
-                </a:solidFill>
-                <a:latin typeface="Calibri"/>
-              </a:rPr>
-              <a:t>LA MEJORA FINAL</a:t>
-            </a:r>
-          </a:p>
-        </p:txBody>
-      </p:sp>
-      <p:sp>
-        <p:nvSpPr>
-          <p:cNvPr id="5" name="TextBox 4"/>
-          <p:cNvSpPr txBox="1"/>
-          <p:nvPr/>
-        </p:nvSpPr>
-        <p:spPr>
-          <a:xfrm>
-            <a:off x="700000" y="430000"/>
-            <a:ext cx="10800000" cy="650000"/>
-          </a:xfrm>
-          <a:prstGeom prst="rect">
-            <a:avLst/>
-          </a:prstGeom>
-          <a:noFill/>
-        </p:spPr>
-        <p:txBody>
-          <a:bodyPr wrap="square">
-            <a:spAutoFit/>
-          </a:bodyPr>
-          <a:lstStyle/>
-          <a:p>
-            <a:r>
-              <a:rPr sz="3000" b="1">
-                <a:solidFill>
-                  <a:srgbClr val="1C3087"/>
-                </a:solidFill>
-                <a:latin typeface="Calibri"/>
-              </a:rPr>
-              <a:t>Calibracion de escala sobre Ronda 8</a:t>
-            </a:r>
-          </a:p>
-        </p:txBody>
-      </p:sp>
-      <p:pic>
-        <p:nvPicPr>
-          <p:cNvPr id="6" name="Picture 5" descr="chart_scale_sweep.png"/>
-          <p:cNvPicPr>
-            <a:picLocks noChangeAspect="1"/>
-          </p:cNvPicPr>
-          <p:nvPr/>
-        </p:nvPicPr>
-        <p:blipFill>
-          <a:blip r:embed="rId3"/>
-          <a:stretch>
-            <a:fillRect/>
-          </a:stretch>
-        </p:blipFill>
-        <p:spPr>
-          <a:xfrm>
-            <a:off x="1350000" y="1500000"/>
-            <a:ext cx="9600000" cy="4648421"/>
-          </a:xfrm>
-          <a:prstGeom prst="rect">
-            <a:avLst/>
-          </a:prstGeom>
-        </p:spPr>
-      </p:pic>
-      <p:sp>
-        <p:nvSpPr>
           <p:cNvPr id="7" name="TextBox 6"/>
           <p:cNvSpPr txBox="1"/>
           <p:nvPr/>
         </p:nvSpPr>
         <p:spPr>
           <a:xfrm>
-            <a:off x="700000" y="6000000"/>
-            <a:ext cx="10800000" cy="800000"/>
+            <a:off x="700000" y="6150000"/>
+            <a:ext cx="10800000" cy="650000"/>
           </a:xfrm>
           <a:prstGeom prst="rect">
             <a:avLst/>
@@ -5787,13 +5805,13 @@
               </a:spcAft>
             </a:pPr>
             <a:r>
-              <a:rPr sz="1400">
+              <a:rPr sz="1300">
                 <a:solidFill>
                   <a:srgbClr val="222222"/>
                 </a:solidFill>
                 <a:latin typeface="Calibri"/>
               </a:rPr>
-              <a:t>Validado con 3 corridas independientes en el dashboard real: escala 0.83 le gano a Ronda 8 sin escalar por 2x a 4x en Mean ROI, sin excepciones.</a:t>
+              <a:t>Validado de verdad con 3 corridas independientes en el dashboard real: ahi escala 0.83 le gano a 0.85 y a Ronda 8 sin escalar, por 2x a 4x en Mean ROI, sin excepciones.</a:t>
             </a:r>
           </a:p>
         </p:txBody>

</xml_diff>

<commit_message>
Sesion 2026-08-03: guia de estudio (20 preguntas + multiple choice)
Se agrega un anexo a la version imprimible (unica, a pedido) con:
- 20 preguntas y respuestas, de basicas a avanzadas, cubriendo mecanica del
  juego, las 12 rondas, Kelly, Edge y la decision final — pensado como
  repaso para la defensa oral
- 15 preguntas de multiple choice para autoevaluacion, con hoja de
  respuestas separada al final (opciones correctas distribuidas parejo
  entre A/B/C/D, no todas en la misma letra)

El PDF a color y el PPT quedan sin cambios de contenido.
</commit_message>
<xml_diff>
--- a/reports/resumen_proyecto_SAM.pptx
+++ b/reports/resumen_proyecto_SAM.pptx
@@ -5,18 +5,18 @@
     <p:sldMasterId id="2147483648" r:id="rId1"/>
   </p:sldMasterIdLst>
   <p:sldIdLst>
-    <p:sldId id="256" r:id="rId7"/>
-    <p:sldId id="257" r:id="rId8"/>
-    <p:sldId id="258" r:id="rId9"/>
-    <p:sldId id="259" r:id="rId10"/>
-    <p:sldId id="260" r:id="rId11"/>
-    <p:sldId id="261" r:id="rId12"/>
-    <p:sldId id="262" r:id="rId13"/>
-    <p:sldId id="263" r:id="rId14"/>
-    <p:sldId id="264" r:id="rId15"/>
-    <p:sldId id="265" r:id="rId16"/>
+    <p:sldId id="256" r:id="rId2"/>
+    <p:sldId id="257" r:id="rId3"/>
+    <p:sldId id="258" r:id="rId4"/>
+    <p:sldId id="259" r:id="rId5"/>
+    <p:sldId id="260" r:id="rId6"/>
+    <p:sldId id="261" r:id="rId7"/>
+    <p:sldId id="262" r:id="rId8"/>
+    <p:sldId id="263" r:id="rId9"/>
+    <p:sldId id="264" r:id="rId10"/>
+    <p:sldId id="265" r:id="rId11"/>
   </p:sldIdLst>
-  <p:sldSz cx="12192000" cy="6858000" type="screen4x3"/>
+  <p:sldSz cx="12192000" cy="6858000"/>
   <p:notesSz cx="6858000" cy="9144000"/>
   <p:defaultTextStyle>
     <a:defPPr>
@@ -113,6 +113,22 @@
       </a:defRPr>
     </a:lvl9pPr>
   </p:defaultTextStyle>
+  <p:extLst>
+    <p:ext uri="{EFAFB233-063F-42B5-8137-9DF3F51BA10A}">
+      <p15:sldGuideLst xmlns:p15="http://schemas.microsoft.com/office/powerpoint/2012/main">
+        <p15:guide id="1" orient="horz" pos="2160">
+          <p15:clr>
+            <a:srgbClr val="A4A3A4"/>
+          </p15:clr>
+        </p15:guide>
+        <p15:guide id="2" pos="2880">
+          <p15:clr>
+            <a:srgbClr val="A4A3A4"/>
+          </p15:clr>
+        </p15:guide>
+      </p15:sldGuideLst>
+    </p:ext>
+  </p:extLst>
 </p:presentation>
 </file>
 
@@ -154,10 +170,9 @@
           <a:lstStyle/>
           <a:p>
             <a:r>
-              <a:rPr lang="en-US" smtClean="0"/>
+              <a:rPr lang="en-US"/>
               <a:t>Click to edit Master title style</a:t>
             </a:r>
-            <a:endParaRPr lang="en-US"/>
           </a:p>
         </p:txBody>
       </p:sp>
@@ -273,10 +288,9 @@
           </a:lstStyle>
           <a:p>
             <a:r>
-              <a:rPr lang="en-US" smtClean="0"/>
+              <a:rPr lang="en-US"/>
               <a:t>Click to edit Master subtitle style</a:t>
             </a:r>
-            <a:endParaRPr lang="en-US"/>
           </a:p>
         </p:txBody>
       </p:sp>
@@ -297,7 +311,7 @@
           <a:p>
             <a:fld id="{5BCAD085-E8A6-8845-BD4E-CB4CCA059FC4}" type="datetimeFigureOut">
               <a:rPr lang="en-US" smtClean="0"/>
-              <a:t>1/27/13</a:t>
+              <a:t>8/4/2026</a:t>
             </a:fld>
             <a:endParaRPr lang="en-US"/>
           </a:p>
@@ -339,7 +353,7 @@
           <a:p>
             <a:fld id="{C1FF6DA9-008F-8B48-92A6-B652298478BF}" type="slidenum">
               <a:rPr lang="en-US" smtClean="0"/>
-              <a:t>‹#›</a:t>
+              <a:t>‹Nº›</a:t>
             </a:fld>
             <a:endParaRPr lang="en-US"/>
           </a:p>
@@ -391,10 +405,9 @@
           <a:lstStyle/>
           <a:p>
             <a:r>
-              <a:rPr lang="en-US" smtClean="0"/>
+              <a:rPr lang="en-US"/>
               <a:t>Click to edit Master title style</a:t>
             </a:r>
-            <a:endParaRPr lang="en-US"/>
           </a:p>
         </p:txBody>
       </p:sp>
@@ -415,38 +428,37 @@
           <a:p>
             <a:pPr lvl="0"/>
             <a:r>
-              <a:rPr lang="en-US" smtClean="0"/>
+              <a:rPr lang="en-US"/>
               <a:t>Click to edit Master text styles</a:t>
             </a:r>
           </a:p>
           <a:p>
             <a:pPr lvl="1"/>
             <a:r>
-              <a:rPr lang="en-US" smtClean="0"/>
+              <a:rPr lang="en-US"/>
               <a:t>Second level</a:t>
             </a:r>
           </a:p>
           <a:p>
             <a:pPr lvl="2"/>
             <a:r>
-              <a:rPr lang="en-US" smtClean="0"/>
+              <a:rPr lang="en-US"/>
               <a:t>Third level</a:t>
             </a:r>
           </a:p>
           <a:p>
             <a:pPr lvl="3"/>
             <a:r>
-              <a:rPr lang="en-US" smtClean="0"/>
+              <a:rPr lang="en-US"/>
               <a:t>Fourth level</a:t>
             </a:r>
           </a:p>
           <a:p>
             <a:pPr lvl="4"/>
             <a:r>
-              <a:rPr lang="en-US" smtClean="0"/>
+              <a:rPr lang="en-US"/>
               <a:t>Fifth level</a:t>
             </a:r>
-            <a:endParaRPr lang="en-US"/>
           </a:p>
         </p:txBody>
       </p:sp>
@@ -467,7 +479,7 @@
           <a:p>
             <a:fld id="{5BCAD085-E8A6-8845-BD4E-CB4CCA059FC4}" type="datetimeFigureOut">
               <a:rPr lang="en-US" smtClean="0"/>
-              <a:t>1/27/13</a:t>
+              <a:t>8/4/2026</a:t>
             </a:fld>
             <a:endParaRPr lang="en-US"/>
           </a:p>
@@ -509,7 +521,7 @@
           <a:p>
             <a:fld id="{C1FF6DA9-008F-8B48-92A6-B652298478BF}" type="slidenum">
               <a:rPr lang="en-US" smtClean="0"/>
-              <a:t>‹#›</a:t>
+              <a:t>‹Nº›</a:t>
             </a:fld>
             <a:endParaRPr lang="en-US"/>
           </a:p>
@@ -566,10 +578,9 @@
           <a:lstStyle/>
           <a:p>
             <a:r>
-              <a:rPr lang="en-US" smtClean="0"/>
+              <a:rPr lang="en-US"/>
               <a:t>Click to edit Master title style</a:t>
             </a:r>
-            <a:endParaRPr lang="en-US"/>
           </a:p>
         </p:txBody>
       </p:sp>
@@ -595,38 +606,37 @@
           <a:p>
             <a:pPr lvl="0"/>
             <a:r>
-              <a:rPr lang="en-US" smtClean="0"/>
+              <a:rPr lang="en-US"/>
               <a:t>Click to edit Master text styles</a:t>
             </a:r>
           </a:p>
           <a:p>
             <a:pPr lvl="1"/>
             <a:r>
-              <a:rPr lang="en-US" smtClean="0"/>
+              <a:rPr lang="en-US"/>
               <a:t>Second level</a:t>
             </a:r>
           </a:p>
           <a:p>
             <a:pPr lvl="2"/>
             <a:r>
-              <a:rPr lang="en-US" smtClean="0"/>
+              <a:rPr lang="en-US"/>
               <a:t>Third level</a:t>
             </a:r>
           </a:p>
           <a:p>
             <a:pPr lvl="3"/>
             <a:r>
-              <a:rPr lang="en-US" smtClean="0"/>
+              <a:rPr lang="en-US"/>
               <a:t>Fourth level</a:t>
             </a:r>
           </a:p>
           <a:p>
             <a:pPr lvl="4"/>
             <a:r>
-              <a:rPr lang="en-US" smtClean="0"/>
+              <a:rPr lang="en-US"/>
               <a:t>Fifth level</a:t>
             </a:r>
-            <a:endParaRPr lang="en-US"/>
           </a:p>
         </p:txBody>
       </p:sp>
@@ -647,7 +657,7 @@
           <a:p>
             <a:fld id="{5BCAD085-E8A6-8845-BD4E-CB4CCA059FC4}" type="datetimeFigureOut">
               <a:rPr lang="en-US" smtClean="0"/>
-              <a:t>1/27/13</a:t>
+              <a:t>8/4/2026</a:t>
             </a:fld>
             <a:endParaRPr lang="en-US"/>
           </a:p>
@@ -689,7 +699,7 @@
           <a:p>
             <a:fld id="{C1FF6DA9-008F-8B48-92A6-B652298478BF}" type="slidenum">
               <a:rPr lang="en-US" smtClean="0"/>
-              <a:t>‹#›</a:t>
+              <a:t>‹Nº›</a:t>
             </a:fld>
             <a:endParaRPr lang="en-US"/>
           </a:p>
@@ -741,10 +751,9 @@
           <a:lstStyle/>
           <a:p>
             <a:r>
-              <a:rPr lang="en-US" smtClean="0"/>
+              <a:rPr lang="en-US"/>
               <a:t>Click to edit Master title style</a:t>
             </a:r>
-            <a:endParaRPr lang="en-US"/>
           </a:p>
         </p:txBody>
       </p:sp>
@@ -765,38 +774,37 @@
           <a:p>
             <a:pPr lvl="0"/>
             <a:r>
-              <a:rPr lang="en-US" smtClean="0"/>
+              <a:rPr lang="en-US"/>
               <a:t>Click to edit Master text styles</a:t>
             </a:r>
           </a:p>
           <a:p>
             <a:pPr lvl="1"/>
             <a:r>
-              <a:rPr lang="en-US" smtClean="0"/>
+              <a:rPr lang="en-US"/>
               <a:t>Second level</a:t>
             </a:r>
           </a:p>
           <a:p>
             <a:pPr lvl="2"/>
             <a:r>
-              <a:rPr lang="en-US" smtClean="0"/>
+              <a:rPr lang="en-US"/>
               <a:t>Third level</a:t>
             </a:r>
           </a:p>
           <a:p>
             <a:pPr lvl="3"/>
             <a:r>
-              <a:rPr lang="en-US" smtClean="0"/>
+              <a:rPr lang="en-US"/>
               <a:t>Fourth level</a:t>
             </a:r>
           </a:p>
           <a:p>
             <a:pPr lvl="4"/>
             <a:r>
-              <a:rPr lang="en-US" smtClean="0"/>
+              <a:rPr lang="en-US"/>
               <a:t>Fifth level</a:t>
             </a:r>
-            <a:endParaRPr lang="en-US"/>
           </a:p>
         </p:txBody>
       </p:sp>
@@ -817,7 +825,7 @@
           <a:p>
             <a:fld id="{5BCAD085-E8A6-8845-BD4E-CB4CCA059FC4}" type="datetimeFigureOut">
               <a:rPr lang="en-US" smtClean="0"/>
-              <a:t>1/27/13</a:t>
+              <a:t>8/4/2026</a:t>
             </a:fld>
             <a:endParaRPr lang="en-US"/>
           </a:p>
@@ -859,7 +867,7 @@
           <a:p>
             <a:fld id="{C1FF6DA9-008F-8B48-92A6-B652298478BF}" type="slidenum">
               <a:rPr lang="en-US" smtClean="0"/>
-              <a:t>‹#›</a:t>
+              <a:t>‹Nº›</a:t>
             </a:fld>
             <a:endParaRPr lang="en-US"/>
           </a:p>
@@ -920,10 +928,9 @@
           </a:lstStyle>
           <a:p>
             <a:r>
-              <a:rPr lang="en-US" smtClean="0"/>
+              <a:rPr lang="en-US"/>
               <a:t>Click to edit Master title style</a:t>
             </a:r>
-            <a:endParaRPr lang="en-US"/>
           </a:p>
         </p:txBody>
       </p:sp>
@@ -1040,7 +1047,7 @@
           <a:p>
             <a:pPr lvl="0"/>
             <a:r>
-              <a:rPr lang="en-US" smtClean="0"/>
+              <a:rPr lang="en-US"/>
               <a:t>Click to edit Master text styles</a:t>
             </a:r>
           </a:p>
@@ -1063,7 +1070,7 @@
           <a:p>
             <a:fld id="{5BCAD085-E8A6-8845-BD4E-CB4CCA059FC4}" type="datetimeFigureOut">
               <a:rPr lang="en-US" smtClean="0"/>
-              <a:t>1/27/13</a:t>
+              <a:t>8/4/2026</a:t>
             </a:fld>
             <a:endParaRPr lang="en-US"/>
           </a:p>
@@ -1105,7 +1112,7 @@
           <a:p>
             <a:fld id="{C1FF6DA9-008F-8B48-92A6-B652298478BF}" type="slidenum">
               <a:rPr lang="en-US" smtClean="0"/>
-              <a:t>‹#›</a:t>
+              <a:t>‹Nº›</a:t>
             </a:fld>
             <a:endParaRPr lang="en-US"/>
           </a:p>
@@ -1157,10 +1164,9 @@
           <a:lstStyle/>
           <a:p>
             <a:r>
-              <a:rPr lang="en-US" smtClean="0"/>
+              <a:rPr lang="en-US"/>
               <a:t>Click to edit Master title style</a:t>
             </a:r>
-            <a:endParaRPr lang="en-US"/>
           </a:p>
         </p:txBody>
       </p:sp>
@@ -1214,38 +1220,37 @@
           <a:p>
             <a:pPr lvl="0"/>
             <a:r>
-              <a:rPr lang="en-US" smtClean="0"/>
+              <a:rPr lang="en-US"/>
               <a:t>Click to edit Master text styles</a:t>
             </a:r>
           </a:p>
           <a:p>
             <a:pPr lvl="1"/>
             <a:r>
-              <a:rPr lang="en-US" smtClean="0"/>
+              <a:rPr lang="en-US"/>
               <a:t>Second level</a:t>
             </a:r>
           </a:p>
           <a:p>
             <a:pPr lvl="2"/>
             <a:r>
-              <a:rPr lang="en-US" smtClean="0"/>
+              <a:rPr lang="en-US"/>
               <a:t>Third level</a:t>
             </a:r>
           </a:p>
           <a:p>
             <a:pPr lvl="3"/>
             <a:r>
-              <a:rPr lang="en-US" smtClean="0"/>
+              <a:rPr lang="en-US"/>
               <a:t>Fourth level</a:t>
             </a:r>
           </a:p>
           <a:p>
             <a:pPr lvl="4"/>
             <a:r>
-              <a:rPr lang="en-US" smtClean="0"/>
+              <a:rPr lang="en-US"/>
               <a:t>Fifth level</a:t>
             </a:r>
-            <a:endParaRPr lang="en-US"/>
           </a:p>
         </p:txBody>
       </p:sp>
@@ -1299,38 +1304,37 @@
           <a:p>
             <a:pPr lvl="0"/>
             <a:r>
-              <a:rPr lang="en-US" smtClean="0"/>
+              <a:rPr lang="en-US"/>
               <a:t>Click to edit Master text styles</a:t>
             </a:r>
           </a:p>
           <a:p>
             <a:pPr lvl="1"/>
             <a:r>
-              <a:rPr lang="en-US" smtClean="0"/>
+              <a:rPr lang="en-US"/>
               <a:t>Second level</a:t>
             </a:r>
           </a:p>
           <a:p>
             <a:pPr lvl="2"/>
             <a:r>
-              <a:rPr lang="en-US" smtClean="0"/>
+              <a:rPr lang="en-US"/>
               <a:t>Third level</a:t>
             </a:r>
           </a:p>
           <a:p>
             <a:pPr lvl="3"/>
             <a:r>
-              <a:rPr lang="en-US" smtClean="0"/>
+              <a:rPr lang="en-US"/>
               <a:t>Fourth level</a:t>
             </a:r>
           </a:p>
           <a:p>
             <a:pPr lvl="4"/>
             <a:r>
-              <a:rPr lang="en-US" smtClean="0"/>
+              <a:rPr lang="en-US"/>
               <a:t>Fifth level</a:t>
             </a:r>
-            <a:endParaRPr lang="en-US"/>
           </a:p>
         </p:txBody>
       </p:sp>
@@ -1351,7 +1355,7 @@
           <a:p>
             <a:fld id="{5BCAD085-E8A6-8845-BD4E-CB4CCA059FC4}" type="datetimeFigureOut">
               <a:rPr lang="en-US" smtClean="0"/>
-              <a:t>1/27/13</a:t>
+              <a:t>8/4/2026</a:t>
             </a:fld>
             <a:endParaRPr lang="en-US"/>
           </a:p>
@@ -1393,7 +1397,7 @@
           <a:p>
             <a:fld id="{C1FF6DA9-008F-8B48-92A6-B652298478BF}" type="slidenum">
               <a:rPr lang="en-US" smtClean="0"/>
-              <a:t>‹#›</a:t>
+              <a:t>‹Nº›</a:t>
             </a:fld>
             <a:endParaRPr lang="en-US"/>
           </a:p>
@@ -1449,10 +1453,9 @@
           </a:lstStyle>
           <a:p>
             <a:r>
-              <a:rPr lang="en-US" smtClean="0"/>
+              <a:rPr lang="en-US"/>
               <a:t>Click to edit Master title style</a:t>
             </a:r>
-            <a:endParaRPr lang="en-US"/>
           </a:p>
         </p:txBody>
       </p:sp>
@@ -1515,7 +1518,7 @@
           <a:p>
             <a:pPr lvl="0"/>
             <a:r>
-              <a:rPr lang="en-US" smtClean="0"/>
+              <a:rPr lang="en-US"/>
               <a:t>Click to edit Master text styles</a:t>
             </a:r>
           </a:p>
@@ -1571,38 +1574,37 @@
           <a:p>
             <a:pPr lvl="0"/>
             <a:r>
-              <a:rPr lang="en-US" smtClean="0"/>
+              <a:rPr lang="en-US"/>
               <a:t>Click to edit Master text styles</a:t>
             </a:r>
           </a:p>
           <a:p>
             <a:pPr lvl="1"/>
             <a:r>
-              <a:rPr lang="en-US" smtClean="0"/>
+              <a:rPr lang="en-US"/>
               <a:t>Second level</a:t>
             </a:r>
           </a:p>
           <a:p>
             <a:pPr lvl="2"/>
             <a:r>
-              <a:rPr lang="en-US" smtClean="0"/>
+              <a:rPr lang="en-US"/>
               <a:t>Third level</a:t>
             </a:r>
           </a:p>
           <a:p>
             <a:pPr lvl="3"/>
             <a:r>
-              <a:rPr lang="en-US" smtClean="0"/>
+              <a:rPr lang="en-US"/>
               <a:t>Fourth level</a:t>
             </a:r>
           </a:p>
           <a:p>
             <a:pPr lvl="4"/>
             <a:r>
-              <a:rPr lang="en-US" smtClean="0"/>
+              <a:rPr lang="en-US"/>
               <a:t>Fifth level</a:t>
             </a:r>
-            <a:endParaRPr lang="en-US"/>
           </a:p>
         </p:txBody>
       </p:sp>
@@ -1665,7 +1667,7 @@
           <a:p>
             <a:pPr lvl="0"/>
             <a:r>
-              <a:rPr lang="en-US" smtClean="0"/>
+              <a:rPr lang="en-US"/>
               <a:t>Click to edit Master text styles</a:t>
             </a:r>
           </a:p>
@@ -1721,38 +1723,37 @@
           <a:p>
             <a:pPr lvl="0"/>
             <a:r>
-              <a:rPr lang="en-US" smtClean="0"/>
+              <a:rPr lang="en-US"/>
               <a:t>Click to edit Master text styles</a:t>
             </a:r>
           </a:p>
           <a:p>
             <a:pPr lvl="1"/>
             <a:r>
-              <a:rPr lang="en-US" smtClean="0"/>
+              <a:rPr lang="en-US"/>
               <a:t>Second level</a:t>
             </a:r>
           </a:p>
           <a:p>
             <a:pPr lvl="2"/>
             <a:r>
-              <a:rPr lang="en-US" smtClean="0"/>
+              <a:rPr lang="en-US"/>
               <a:t>Third level</a:t>
             </a:r>
           </a:p>
           <a:p>
             <a:pPr lvl="3"/>
             <a:r>
-              <a:rPr lang="en-US" smtClean="0"/>
+              <a:rPr lang="en-US"/>
               <a:t>Fourth level</a:t>
             </a:r>
           </a:p>
           <a:p>
             <a:pPr lvl="4"/>
             <a:r>
-              <a:rPr lang="en-US" smtClean="0"/>
+              <a:rPr lang="en-US"/>
               <a:t>Fifth level</a:t>
             </a:r>
-            <a:endParaRPr lang="en-US"/>
           </a:p>
         </p:txBody>
       </p:sp>
@@ -1773,7 +1774,7 @@
           <a:p>
             <a:fld id="{5BCAD085-E8A6-8845-BD4E-CB4CCA059FC4}" type="datetimeFigureOut">
               <a:rPr lang="en-US" smtClean="0"/>
-              <a:t>1/27/13</a:t>
+              <a:t>8/4/2026</a:t>
             </a:fld>
             <a:endParaRPr lang="en-US"/>
           </a:p>
@@ -1815,7 +1816,7 @@
           <a:p>
             <a:fld id="{C1FF6DA9-008F-8B48-92A6-B652298478BF}" type="slidenum">
               <a:rPr lang="en-US" smtClean="0"/>
-              <a:t>‹#›</a:t>
+              <a:t>‹Nº›</a:t>
             </a:fld>
             <a:endParaRPr lang="en-US"/>
           </a:p>
@@ -1867,10 +1868,9 @@
           <a:lstStyle/>
           <a:p>
             <a:r>
-              <a:rPr lang="en-US" smtClean="0"/>
+              <a:rPr lang="en-US"/>
               <a:t>Click to edit Master title style</a:t>
             </a:r>
-            <a:endParaRPr lang="en-US"/>
           </a:p>
         </p:txBody>
       </p:sp>
@@ -1891,7 +1891,7 @@
           <a:p>
             <a:fld id="{5BCAD085-E8A6-8845-BD4E-CB4CCA059FC4}" type="datetimeFigureOut">
               <a:rPr lang="en-US" smtClean="0"/>
-              <a:t>1/27/13</a:t>
+              <a:t>8/4/2026</a:t>
             </a:fld>
             <a:endParaRPr lang="en-US"/>
           </a:p>
@@ -1933,7 +1933,7 @@
           <a:p>
             <a:fld id="{C1FF6DA9-008F-8B48-92A6-B652298478BF}" type="slidenum">
               <a:rPr lang="en-US" smtClean="0"/>
-              <a:t>‹#›</a:t>
+              <a:t>‹Nº›</a:t>
             </a:fld>
             <a:endParaRPr lang="en-US"/>
           </a:p>
@@ -1986,7 +1986,7 @@
           <a:p>
             <a:fld id="{5BCAD085-E8A6-8845-BD4E-CB4CCA059FC4}" type="datetimeFigureOut">
               <a:rPr lang="en-US" smtClean="0"/>
-              <a:t>1/27/13</a:t>
+              <a:t>8/4/2026</a:t>
             </a:fld>
             <a:endParaRPr lang="en-US"/>
           </a:p>
@@ -2028,7 +2028,7 @@
           <a:p>
             <a:fld id="{C1FF6DA9-008F-8B48-92A6-B652298478BF}" type="slidenum">
               <a:rPr lang="en-US" smtClean="0"/>
-              <a:t>‹#›</a:t>
+              <a:t>‹Nº›</a:t>
             </a:fld>
             <a:endParaRPr lang="en-US"/>
           </a:p>
@@ -2089,10 +2089,9 @@
           </a:lstStyle>
           <a:p>
             <a:r>
-              <a:rPr lang="en-US" smtClean="0"/>
+              <a:rPr lang="en-US"/>
               <a:t>Click to edit Master title style</a:t>
             </a:r>
-            <a:endParaRPr lang="en-US"/>
           </a:p>
         </p:txBody>
       </p:sp>
@@ -2146,38 +2145,37 @@
           <a:p>
             <a:pPr lvl="0"/>
             <a:r>
-              <a:rPr lang="en-US" smtClean="0"/>
+              <a:rPr lang="en-US"/>
               <a:t>Click to edit Master text styles</a:t>
             </a:r>
           </a:p>
           <a:p>
             <a:pPr lvl="1"/>
             <a:r>
-              <a:rPr lang="en-US" smtClean="0"/>
+              <a:rPr lang="en-US"/>
               <a:t>Second level</a:t>
             </a:r>
           </a:p>
           <a:p>
             <a:pPr lvl="2"/>
             <a:r>
-              <a:rPr lang="en-US" smtClean="0"/>
+              <a:rPr lang="en-US"/>
               <a:t>Third level</a:t>
             </a:r>
           </a:p>
           <a:p>
             <a:pPr lvl="3"/>
             <a:r>
-              <a:rPr lang="en-US" smtClean="0"/>
+              <a:rPr lang="en-US"/>
               <a:t>Fourth level</a:t>
             </a:r>
           </a:p>
           <a:p>
             <a:pPr lvl="4"/>
             <a:r>
-              <a:rPr lang="en-US" smtClean="0"/>
+              <a:rPr lang="en-US"/>
               <a:t>Fifth level</a:t>
             </a:r>
-            <a:endParaRPr lang="en-US"/>
           </a:p>
         </p:txBody>
       </p:sp>
@@ -2240,7 +2238,7 @@
           <a:p>
             <a:pPr lvl="0"/>
             <a:r>
-              <a:rPr lang="en-US" smtClean="0"/>
+              <a:rPr lang="en-US"/>
               <a:t>Click to edit Master text styles</a:t>
             </a:r>
           </a:p>
@@ -2263,7 +2261,7 @@
           <a:p>
             <a:fld id="{5BCAD085-E8A6-8845-BD4E-CB4CCA059FC4}" type="datetimeFigureOut">
               <a:rPr lang="en-US" smtClean="0"/>
-              <a:t>1/27/13</a:t>
+              <a:t>8/4/2026</a:t>
             </a:fld>
             <a:endParaRPr lang="en-US"/>
           </a:p>
@@ -2305,7 +2303,7 @@
           <a:p>
             <a:fld id="{C1FF6DA9-008F-8B48-92A6-B652298478BF}" type="slidenum">
               <a:rPr lang="en-US" smtClean="0"/>
-              <a:t>‹#›</a:t>
+              <a:t>‹Nº›</a:t>
             </a:fld>
             <a:endParaRPr lang="en-US"/>
           </a:p>
@@ -2366,10 +2364,9 @@
           </a:lstStyle>
           <a:p>
             <a:r>
-              <a:rPr lang="en-US" smtClean="0"/>
+              <a:rPr lang="en-US"/>
               <a:t>Click to edit Master title style</a:t>
             </a:r>
-            <a:endParaRPr lang="en-US"/>
           </a:p>
         </p:txBody>
       </p:sp>
@@ -2493,7 +2490,7 @@
           <a:p>
             <a:pPr lvl="0"/>
             <a:r>
-              <a:rPr lang="en-US" smtClean="0"/>
+              <a:rPr lang="en-US"/>
               <a:t>Click to edit Master text styles</a:t>
             </a:r>
           </a:p>
@@ -2516,7 +2513,7 @@
           <a:p>
             <a:fld id="{5BCAD085-E8A6-8845-BD4E-CB4CCA059FC4}" type="datetimeFigureOut">
               <a:rPr lang="en-US" smtClean="0"/>
-              <a:t>1/27/13</a:t>
+              <a:t>8/4/2026</a:t>
             </a:fld>
             <a:endParaRPr lang="en-US"/>
           </a:p>
@@ -2558,7 +2555,7 @@
           <a:p>
             <a:fld id="{C1FF6DA9-008F-8B48-92A6-B652298478BF}" type="slidenum">
               <a:rPr lang="en-US" smtClean="0"/>
-              <a:t>‹#›</a:t>
+              <a:t>‹Nº›</a:t>
             </a:fld>
             <a:endParaRPr lang="en-US"/>
           </a:p>
@@ -2625,10 +2622,9 @@
           <a:lstStyle/>
           <a:p>
             <a:r>
-              <a:rPr lang="en-US" smtClean="0"/>
+              <a:rPr lang="en-US"/>
               <a:t>Click to edit Master title style</a:t>
             </a:r>
-            <a:endParaRPr lang="en-US"/>
           </a:p>
         </p:txBody>
       </p:sp>
@@ -2659,38 +2655,37 @@
           <a:p>
             <a:pPr lvl="0"/>
             <a:r>
-              <a:rPr lang="en-US" smtClean="0"/>
+              <a:rPr lang="en-US"/>
               <a:t>Click to edit Master text styles</a:t>
             </a:r>
           </a:p>
           <a:p>
             <a:pPr lvl="1"/>
             <a:r>
-              <a:rPr lang="en-US" smtClean="0"/>
+              <a:rPr lang="en-US"/>
               <a:t>Second level</a:t>
             </a:r>
           </a:p>
           <a:p>
             <a:pPr lvl="2"/>
             <a:r>
-              <a:rPr lang="en-US" smtClean="0"/>
+              <a:rPr lang="en-US"/>
               <a:t>Third level</a:t>
             </a:r>
           </a:p>
           <a:p>
             <a:pPr lvl="3"/>
             <a:r>
-              <a:rPr lang="en-US" smtClean="0"/>
+              <a:rPr lang="en-US"/>
               <a:t>Fourth level</a:t>
             </a:r>
           </a:p>
           <a:p>
             <a:pPr lvl="4"/>
             <a:r>
-              <a:rPr lang="en-US" smtClean="0"/>
+              <a:rPr lang="en-US"/>
               <a:t>Fifth level</a:t>
             </a:r>
-            <a:endParaRPr lang="en-US"/>
           </a:p>
         </p:txBody>
       </p:sp>
@@ -2729,7 +2724,7 @@
           <a:p>
             <a:fld id="{5BCAD085-E8A6-8845-BD4E-CB4CCA059FC4}" type="datetimeFigureOut">
               <a:rPr lang="en-US" smtClean="0"/>
-              <a:t>1/27/13</a:t>
+              <a:t>8/4/2026</a:t>
             </a:fld>
             <a:endParaRPr lang="en-US"/>
           </a:p>
@@ -2807,7 +2802,7 @@
           <a:p>
             <a:fld id="{C1FF6DA9-008F-8B48-92A6-B652298478BF}" type="slidenum">
               <a:rPr lang="en-US" smtClean="0"/>
-              <a:t>‹#›</a:t>
+              <a:t>‹Nº›</a:t>
             </a:fld>
             <a:endParaRPr lang="en-US"/>
           </a:p>
@@ -3088,7 +3083,7 @@
 </file>
 
 <file path=ppt/slides/slide1.xml><?xml version="1.0" encoding="utf-8"?>
-<p:sld xmlns:a="http://schemas.openxmlformats.org/drawingml/2006/main" xmlns:p="http://schemas.openxmlformats.org/presentationml/2006/main" xmlns:r="http://schemas.openxmlformats.org/officeDocument/2006/relationships">
+<p:sld xmlns:a="http://schemas.openxmlformats.org/drawingml/2006/main" xmlns:r="http://schemas.openxmlformats.org/officeDocument/2006/relationships" xmlns:p="http://schemas.openxmlformats.org/presentationml/2006/main">
   <p:cSld>
     <p:spTree>
       <p:nvGrpSpPr>
@@ -3096,7 +3091,14 @@
         <p:cNvGrpSpPr/>
         <p:nvPr/>
       </p:nvGrpSpPr>
-      <p:grpSpPr/>
+      <p:grpSpPr>
+        <a:xfrm>
+          <a:off x="0" y="0"/>
+          <a:ext cx="0" cy="0"/>
+          <a:chOff x="0" y="0"/>
+          <a:chExt cx="0" cy="0"/>
+        </a:xfrm>
+      </p:grpSpPr>
       <p:sp>
         <p:nvSpPr>
           <p:cNvPr id="2" name="Rectangle 1"/>
@@ -3138,6 +3140,7 @@
           <a:lstStyle/>
           <a:p>
             <a:pPr algn="ctr"/>
+            <a:endParaRPr/>
           </a:p>
         </p:txBody>
       </p:sp>
@@ -3182,6 +3185,7 @@
           <a:lstStyle/>
           <a:p>
             <a:pPr algn="ctr"/>
+            <a:endParaRPr/>
           </a:p>
         </p:txBody>
       </p:sp>
@@ -3226,6 +3230,7 @@
           <a:lstStyle/>
           <a:p>
             <a:pPr algn="ctr"/>
+            <a:endParaRPr/>
           </a:p>
         </p:txBody>
       </p:sp>
@@ -3270,6 +3275,7 @@
           <a:lstStyle/>
           <a:p>
             <a:pPr algn="ctr"/>
+            <a:endParaRPr/>
           </a:p>
         </p:txBody>
       </p:sp>
@@ -3414,7 +3420,7 @@
 </file>
 
 <file path=ppt/slides/slide10.xml><?xml version="1.0" encoding="utf-8"?>
-<p:sld xmlns:a="http://schemas.openxmlformats.org/drawingml/2006/main" xmlns:p="http://schemas.openxmlformats.org/presentationml/2006/main" xmlns:r="http://schemas.openxmlformats.org/officeDocument/2006/relationships">
+<p:sld xmlns:a="http://schemas.openxmlformats.org/drawingml/2006/main" xmlns:r="http://schemas.openxmlformats.org/officeDocument/2006/relationships" xmlns:p="http://schemas.openxmlformats.org/presentationml/2006/main">
   <p:cSld>
     <p:spTree>
       <p:nvGrpSpPr>
@@ -3422,7 +3428,14 @@
         <p:cNvGrpSpPr/>
         <p:nvPr/>
       </p:nvGrpSpPr>
-      <p:grpSpPr/>
+      <p:grpSpPr>
+        <a:xfrm>
+          <a:off x="0" y="0"/>
+          <a:ext cx="0" cy="0"/>
+          <a:chOff x="0" y="0"/>
+          <a:chExt cx="0" cy="0"/>
+        </a:xfrm>
+      </p:grpSpPr>
       <p:pic>
         <p:nvPicPr>
           <p:cNvPr id="2" name="Picture 1" descr="austral_closing_bg.jpg"/>
@@ -3489,7 +3502,7 @@
 </file>
 
 <file path=ppt/slides/slide2.xml><?xml version="1.0" encoding="utf-8"?>
-<p:sld xmlns:a="http://schemas.openxmlformats.org/drawingml/2006/main" xmlns:p="http://schemas.openxmlformats.org/presentationml/2006/main" xmlns:r="http://schemas.openxmlformats.org/officeDocument/2006/relationships">
+<p:sld xmlns:a="http://schemas.openxmlformats.org/drawingml/2006/main" xmlns:r="http://schemas.openxmlformats.org/officeDocument/2006/relationships" xmlns:p="http://schemas.openxmlformats.org/presentationml/2006/main" show="0">
   <p:cSld>
     <p:spTree>
       <p:nvGrpSpPr>
@@ -3497,7 +3510,14 @@
         <p:cNvGrpSpPr/>
         <p:nvPr/>
       </p:nvGrpSpPr>
-      <p:grpSpPr/>
+      <p:grpSpPr>
+        <a:xfrm>
+          <a:off x="0" y="0"/>
+          <a:ext cx="0" cy="0"/>
+          <a:chOff x="0" y="0"/>
+          <a:chExt cx="0" cy="0"/>
+        </a:xfrm>
+      </p:grpSpPr>
       <p:sp>
         <p:nvSpPr>
           <p:cNvPr id="2" name="Right Triangle 1"/>
@@ -3539,6 +3559,7 @@
           <a:lstStyle/>
           <a:p>
             <a:pPr algn="ctr"/>
+            <a:endParaRPr/>
           </a:p>
         </p:txBody>
       </p:sp>
@@ -3806,7 +3827,7 @@
 </file>
 
 <file path=ppt/slides/slide3.xml><?xml version="1.0" encoding="utf-8"?>
-<p:sld xmlns:a="http://schemas.openxmlformats.org/drawingml/2006/main" xmlns:p="http://schemas.openxmlformats.org/presentationml/2006/main" xmlns:r="http://schemas.openxmlformats.org/officeDocument/2006/relationships">
+<p:sld xmlns:a="http://schemas.openxmlformats.org/drawingml/2006/main" xmlns:r="http://schemas.openxmlformats.org/officeDocument/2006/relationships" xmlns:p="http://schemas.openxmlformats.org/presentationml/2006/main">
   <p:cSld>
     <p:spTree>
       <p:nvGrpSpPr>
@@ -3814,7 +3835,14 @@
         <p:cNvGrpSpPr/>
         <p:nvPr/>
       </p:nvGrpSpPr>
-      <p:grpSpPr/>
+      <p:grpSpPr>
+        <a:xfrm>
+          <a:off x="0" y="0"/>
+          <a:ext cx="0" cy="0"/>
+          <a:chOff x="0" y="0"/>
+          <a:chExt cx="0" cy="0"/>
+        </a:xfrm>
+      </p:grpSpPr>
       <p:sp>
         <p:nvSpPr>
           <p:cNvPr id="2" name="Right Triangle 1"/>
@@ -3823,7 +3851,7 @@
         </p:nvSpPr>
         <p:spPr>
           <a:xfrm>
-            <a:off x="186158" y="-198852"/>
+            <a:off x="0" y="0"/>
             <a:ext cx="1901656" cy="2273969"/>
           </a:xfrm>
           <a:prstGeom prst="rtTriangle">
@@ -3856,6 +3884,7 @@
           <a:lstStyle/>
           <a:p>
             <a:pPr algn="ctr"/>
+            <a:endParaRPr/>
           </a:p>
         </p:txBody>
       </p:sp>
@@ -3970,14 +3999,32 @@
                 <a:tableStyleId>{5C22544A-7EE6-4342-B048-85BDC9FD1C3A}</a:tableStyleId>
               </a:tblPr>
               <a:tblGrid>
-                <a:gridCol w="1600000"/>
-                <a:gridCol w="7600000"/>
-                <a:gridCol w="1600000"/>
+                <a:gridCol w="1600000">
+                  <a:extLst>
+                    <a:ext uri="{9D8B030D-6E8A-4147-A177-3AD203B41FA5}">
+                      <a16:colId xmlns:a16="http://schemas.microsoft.com/office/drawing/2014/main" val="20000"/>
+                    </a:ext>
+                  </a:extLst>
+                </a:gridCol>
+                <a:gridCol w="7600000">
+                  <a:extLst>
+                    <a:ext uri="{9D8B030D-6E8A-4147-A177-3AD203B41FA5}">
+                      <a16:colId xmlns:a16="http://schemas.microsoft.com/office/drawing/2014/main" val="20001"/>
+                    </a:ext>
+                  </a:extLst>
+                </a:gridCol>
+                <a:gridCol w="1600000">
+                  <a:extLst>
+                    <a:ext uri="{9D8B030D-6E8A-4147-A177-3AD203B41FA5}">
+                      <a16:colId xmlns:a16="http://schemas.microsoft.com/office/drawing/2014/main" val="20002"/>
+                    </a:ext>
+                  </a:extLst>
+                </a:gridCol>
               </a:tblGrid>
               <a:tr h="350000">
                 <a:tc>
                   <a:txBody>
-                    <a:bodyPr wrap="square"/>
+                    <a:bodyPr/>
                     <a:lstStyle/>
                     <a:p>
                       <a:pPr algn="l"/>
@@ -4000,7 +4047,7 @@
                 </a:tc>
                 <a:tc>
                   <a:txBody>
-                    <a:bodyPr wrap="square"/>
+                    <a:bodyPr/>
                     <a:lstStyle/>
                     <a:p>
                       <a:pPr algn="l"/>
@@ -4023,7 +4070,7 @@
                 </a:tc>
                 <a:tc>
                   <a:txBody>
-                    <a:bodyPr wrap="square"/>
+                    <a:bodyPr/>
                     <a:lstStyle/>
                     <a:p>
                       <a:pPr algn="ctr"/>
@@ -4044,11 +4091,16 @@
                     </a:solidFill>
                   </a:tcPr>
                 </a:tc>
+                <a:extLst>
+                  <a:ext uri="{0D108BD9-81ED-4DB2-BD59-A6C34878D82A}">
+                    <a16:rowId xmlns:a16="http://schemas.microsoft.com/office/drawing/2014/main" val="10000"/>
+                  </a:ext>
+                </a:extLst>
               </a:tr>
               <a:tr h="350000">
                 <a:tc>
                   <a:txBody>
-                    <a:bodyPr wrap="square"/>
+                    <a:bodyPr/>
                     <a:lstStyle/>
                     <a:p>
                       <a:pPr algn="l"/>
@@ -4071,7 +4123,7 @@
                 </a:tc>
                 <a:tc>
                   <a:txBody>
-                    <a:bodyPr wrap="square"/>
+                    <a:bodyPr/>
                     <a:lstStyle/>
                     <a:p>
                       <a:pPr algn="l"/>
@@ -4094,7 +4146,7 @@
                 </a:tc>
                 <a:tc>
                   <a:txBody>
-                    <a:bodyPr wrap="square"/>
+                    <a:bodyPr/>
                     <a:lstStyle/>
                     <a:p>
                       <a:pPr algn="ctr"/>
@@ -4115,11 +4167,16 @@
                     </a:solidFill>
                   </a:tcPr>
                 </a:tc>
+                <a:extLst>
+                  <a:ext uri="{0D108BD9-81ED-4DB2-BD59-A6C34878D82A}">
+                    <a16:rowId xmlns:a16="http://schemas.microsoft.com/office/drawing/2014/main" val="10001"/>
+                  </a:ext>
+                </a:extLst>
               </a:tr>
               <a:tr h="350000">
                 <a:tc>
                   <a:txBody>
-                    <a:bodyPr wrap="square"/>
+                    <a:bodyPr/>
                     <a:lstStyle/>
                     <a:p>
                       <a:pPr algn="l"/>
@@ -4142,7 +4199,7 @@
                 </a:tc>
                 <a:tc>
                   <a:txBody>
-                    <a:bodyPr wrap="square"/>
+                    <a:bodyPr/>
                     <a:lstStyle/>
                     <a:p>
                       <a:pPr algn="l"/>
@@ -4165,7 +4222,7 @@
                 </a:tc>
                 <a:tc>
                   <a:txBody>
-                    <a:bodyPr wrap="square"/>
+                    <a:bodyPr/>
                     <a:lstStyle/>
                     <a:p>
                       <a:pPr algn="ctr"/>
@@ -4186,11 +4243,16 @@
                     </a:solidFill>
                   </a:tcPr>
                 </a:tc>
+                <a:extLst>
+                  <a:ext uri="{0D108BD9-81ED-4DB2-BD59-A6C34878D82A}">
+                    <a16:rowId xmlns:a16="http://schemas.microsoft.com/office/drawing/2014/main" val="10002"/>
+                  </a:ext>
+                </a:extLst>
               </a:tr>
               <a:tr h="350000">
                 <a:tc>
                   <a:txBody>
-                    <a:bodyPr wrap="square"/>
+                    <a:bodyPr/>
                     <a:lstStyle/>
                     <a:p>
                       <a:pPr algn="l"/>
@@ -4213,7 +4275,7 @@
                 </a:tc>
                 <a:tc>
                   <a:txBody>
-                    <a:bodyPr wrap="square"/>
+                    <a:bodyPr/>
                     <a:lstStyle/>
                     <a:p>
                       <a:pPr algn="l"/>
@@ -4236,7 +4298,7 @@
                 </a:tc>
                 <a:tc>
                   <a:txBody>
-                    <a:bodyPr wrap="square"/>
+                    <a:bodyPr/>
                     <a:lstStyle/>
                     <a:p>
                       <a:pPr algn="ctr"/>
@@ -4257,11 +4319,16 @@
                     </a:solidFill>
                   </a:tcPr>
                 </a:tc>
+                <a:extLst>
+                  <a:ext uri="{0D108BD9-81ED-4DB2-BD59-A6C34878D82A}">
+                    <a16:rowId xmlns:a16="http://schemas.microsoft.com/office/drawing/2014/main" val="10003"/>
+                  </a:ext>
+                </a:extLst>
               </a:tr>
               <a:tr h="350000">
                 <a:tc>
                   <a:txBody>
-                    <a:bodyPr wrap="square"/>
+                    <a:bodyPr/>
                     <a:lstStyle/>
                     <a:p>
                       <a:pPr algn="l"/>
@@ -4284,7 +4351,7 @@
                 </a:tc>
                 <a:tc>
                   <a:txBody>
-                    <a:bodyPr wrap="square"/>
+                    <a:bodyPr/>
                     <a:lstStyle/>
                     <a:p>
                       <a:pPr algn="l"/>
@@ -4307,7 +4374,7 @@
                 </a:tc>
                 <a:tc>
                   <a:txBody>
-                    <a:bodyPr wrap="square"/>
+                    <a:bodyPr/>
                     <a:lstStyle/>
                     <a:p>
                       <a:pPr algn="ctr"/>
@@ -4328,11 +4395,16 @@
                     </a:solidFill>
                   </a:tcPr>
                 </a:tc>
+                <a:extLst>
+                  <a:ext uri="{0D108BD9-81ED-4DB2-BD59-A6C34878D82A}">
+                    <a16:rowId xmlns:a16="http://schemas.microsoft.com/office/drawing/2014/main" val="10004"/>
+                  </a:ext>
+                </a:extLst>
               </a:tr>
               <a:tr h="350000">
                 <a:tc>
                   <a:txBody>
-                    <a:bodyPr wrap="square"/>
+                    <a:bodyPr/>
                     <a:lstStyle/>
                     <a:p>
                       <a:pPr algn="l"/>
@@ -4355,7 +4427,7 @@
                 </a:tc>
                 <a:tc>
                   <a:txBody>
-                    <a:bodyPr wrap="square"/>
+                    <a:bodyPr/>
                     <a:lstStyle/>
                     <a:p>
                       <a:pPr algn="l"/>
@@ -4378,7 +4450,7 @@
                 </a:tc>
                 <a:tc>
                   <a:txBody>
-                    <a:bodyPr wrap="square"/>
+                    <a:bodyPr/>
                     <a:lstStyle/>
                     <a:p>
                       <a:pPr algn="ctr"/>
@@ -4399,11 +4471,16 @@
                     </a:solidFill>
                   </a:tcPr>
                 </a:tc>
+                <a:extLst>
+                  <a:ext uri="{0D108BD9-81ED-4DB2-BD59-A6C34878D82A}">
+                    <a16:rowId xmlns:a16="http://schemas.microsoft.com/office/drawing/2014/main" val="10005"/>
+                  </a:ext>
+                </a:extLst>
               </a:tr>
               <a:tr h="350000">
                 <a:tc>
                   <a:txBody>
-                    <a:bodyPr wrap="square"/>
+                    <a:bodyPr/>
                     <a:lstStyle/>
                     <a:p>
                       <a:pPr algn="l"/>
@@ -4426,7 +4503,7 @@
                 </a:tc>
                 <a:tc>
                   <a:txBody>
-                    <a:bodyPr wrap="square"/>
+                    <a:bodyPr/>
                     <a:lstStyle/>
                     <a:p>
                       <a:pPr algn="l"/>
@@ -4449,7 +4526,7 @@
                 </a:tc>
                 <a:tc>
                   <a:txBody>
-                    <a:bodyPr wrap="square"/>
+                    <a:bodyPr/>
                     <a:lstStyle/>
                     <a:p>
                       <a:pPr algn="ctr"/>
@@ -4470,11 +4547,16 @@
                     </a:solidFill>
                   </a:tcPr>
                 </a:tc>
+                <a:extLst>
+                  <a:ext uri="{0D108BD9-81ED-4DB2-BD59-A6C34878D82A}">
+                    <a16:rowId xmlns:a16="http://schemas.microsoft.com/office/drawing/2014/main" val="10006"/>
+                  </a:ext>
+                </a:extLst>
               </a:tr>
               <a:tr h="350000">
                 <a:tc>
                   <a:txBody>
-                    <a:bodyPr wrap="square"/>
+                    <a:bodyPr/>
                     <a:lstStyle/>
                     <a:p>
                       <a:pPr algn="l"/>
@@ -4497,7 +4579,7 @@
                 </a:tc>
                 <a:tc>
                   <a:txBody>
-                    <a:bodyPr wrap="square"/>
+                    <a:bodyPr/>
                     <a:lstStyle/>
                     <a:p>
                       <a:pPr algn="l"/>
@@ -4520,7 +4602,7 @@
                 </a:tc>
                 <a:tc>
                   <a:txBody>
-                    <a:bodyPr wrap="square"/>
+                    <a:bodyPr/>
                     <a:lstStyle/>
                     <a:p>
                       <a:pPr algn="ctr"/>
@@ -4541,11 +4623,16 @@
                     </a:solidFill>
                   </a:tcPr>
                 </a:tc>
+                <a:extLst>
+                  <a:ext uri="{0D108BD9-81ED-4DB2-BD59-A6C34878D82A}">
+                    <a16:rowId xmlns:a16="http://schemas.microsoft.com/office/drawing/2014/main" val="10007"/>
+                  </a:ext>
+                </a:extLst>
               </a:tr>
               <a:tr h="350000">
                 <a:tc>
                   <a:txBody>
-                    <a:bodyPr wrap="square"/>
+                    <a:bodyPr/>
                     <a:lstStyle/>
                     <a:p>
                       <a:pPr algn="l"/>
@@ -4568,7 +4655,7 @@
                 </a:tc>
                 <a:tc>
                   <a:txBody>
-                    <a:bodyPr wrap="square"/>
+                    <a:bodyPr/>
                     <a:lstStyle/>
                     <a:p>
                       <a:pPr algn="l"/>
@@ -4591,7 +4678,7 @@
                 </a:tc>
                 <a:tc>
                   <a:txBody>
-                    <a:bodyPr wrap="square"/>
+                    <a:bodyPr/>
                     <a:lstStyle/>
                     <a:p>
                       <a:pPr algn="ctr"/>
@@ -4612,11 +4699,16 @@
                     </a:solidFill>
                   </a:tcPr>
                 </a:tc>
+                <a:extLst>
+                  <a:ext uri="{0D108BD9-81ED-4DB2-BD59-A6C34878D82A}">
+                    <a16:rowId xmlns:a16="http://schemas.microsoft.com/office/drawing/2014/main" val="10008"/>
+                  </a:ext>
+                </a:extLst>
               </a:tr>
               <a:tr h="350000">
                 <a:tc>
                   <a:txBody>
-                    <a:bodyPr wrap="square"/>
+                    <a:bodyPr/>
                     <a:lstStyle/>
                     <a:p>
                       <a:pPr algn="l"/>
@@ -4639,7 +4731,7 @@
                 </a:tc>
                 <a:tc>
                   <a:txBody>
-                    <a:bodyPr wrap="square"/>
+                    <a:bodyPr/>
                     <a:lstStyle/>
                     <a:p>
                       <a:pPr algn="l"/>
@@ -4662,7 +4754,7 @@
                 </a:tc>
                 <a:tc>
                   <a:txBody>
-                    <a:bodyPr wrap="square"/>
+                    <a:bodyPr/>
                     <a:lstStyle/>
                     <a:p>
                       <a:pPr algn="ctr"/>
@@ -4683,11 +4775,16 @@
                     </a:solidFill>
                   </a:tcPr>
                 </a:tc>
+                <a:extLst>
+                  <a:ext uri="{0D108BD9-81ED-4DB2-BD59-A6C34878D82A}">
+                    <a16:rowId xmlns:a16="http://schemas.microsoft.com/office/drawing/2014/main" val="10009"/>
+                  </a:ext>
+                </a:extLst>
               </a:tr>
               <a:tr h="350000">
                 <a:tc>
                   <a:txBody>
-                    <a:bodyPr wrap="square"/>
+                    <a:bodyPr/>
                     <a:lstStyle/>
                     <a:p>
                       <a:pPr algn="l"/>
@@ -4710,7 +4807,7 @@
                 </a:tc>
                 <a:tc>
                   <a:txBody>
-                    <a:bodyPr wrap="square"/>
+                    <a:bodyPr/>
                     <a:lstStyle/>
                     <a:p>
                       <a:pPr algn="l"/>
@@ -4733,7 +4830,7 @@
                 </a:tc>
                 <a:tc>
                   <a:txBody>
-                    <a:bodyPr wrap="square"/>
+                    <a:bodyPr/>
                     <a:lstStyle/>
                     <a:p>
                       <a:pPr algn="ctr"/>
@@ -4754,11 +4851,16 @@
                     </a:solidFill>
                   </a:tcPr>
                 </a:tc>
+                <a:extLst>
+                  <a:ext uri="{0D108BD9-81ED-4DB2-BD59-A6C34878D82A}">
+                    <a16:rowId xmlns:a16="http://schemas.microsoft.com/office/drawing/2014/main" val="10010"/>
+                  </a:ext>
+                </a:extLst>
               </a:tr>
               <a:tr h="350000">
                 <a:tc>
                   <a:txBody>
-                    <a:bodyPr wrap="square"/>
+                    <a:bodyPr/>
                     <a:lstStyle/>
                     <a:p>
                       <a:pPr algn="l"/>
@@ -4781,7 +4883,7 @@
                 </a:tc>
                 <a:tc>
                   <a:txBody>
-                    <a:bodyPr wrap="square"/>
+                    <a:bodyPr/>
                     <a:lstStyle/>
                     <a:p>
                       <a:pPr algn="l"/>
@@ -4804,7 +4906,7 @@
                 </a:tc>
                 <a:tc>
                   <a:txBody>
-                    <a:bodyPr wrap="square"/>
+                    <a:bodyPr/>
                     <a:lstStyle/>
                     <a:p>
                       <a:pPr algn="ctr"/>
@@ -4825,11 +4927,16 @@
                     </a:solidFill>
                   </a:tcPr>
                 </a:tc>
+                <a:extLst>
+                  <a:ext uri="{0D108BD9-81ED-4DB2-BD59-A6C34878D82A}">
+                    <a16:rowId xmlns:a16="http://schemas.microsoft.com/office/drawing/2014/main" val="10011"/>
+                  </a:ext>
+                </a:extLst>
               </a:tr>
               <a:tr h="350000">
                 <a:tc>
                   <a:txBody>
-                    <a:bodyPr wrap="square"/>
+                    <a:bodyPr/>
                     <a:lstStyle/>
                     <a:p>
                       <a:pPr algn="l"/>
@@ -4852,7 +4959,7 @@
                 </a:tc>
                 <a:tc>
                   <a:txBody>
-                    <a:bodyPr wrap="square"/>
+                    <a:bodyPr/>
                     <a:lstStyle/>
                     <a:p>
                       <a:pPr algn="l"/>
@@ -4875,7 +4982,7 @@
                 </a:tc>
                 <a:tc>
                   <a:txBody>
-                    <a:bodyPr wrap="square"/>
+                    <a:bodyPr/>
                     <a:lstStyle/>
                     <a:p>
                       <a:pPr algn="ctr"/>
@@ -4896,11 +5003,16 @@
                     </a:solidFill>
                   </a:tcPr>
                 </a:tc>
+                <a:extLst>
+                  <a:ext uri="{0D108BD9-81ED-4DB2-BD59-A6C34878D82A}">
+                    <a16:rowId xmlns:a16="http://schemas.microsoft.com/office/drawing/2014/main" val="10012"/>
+                  </a:ext>
+                </a:extLst>
               </a:tr>
               <a:tr h="350000">
                 <a:tc>
                   <a:txBody>
-                    <a:bodyPr wrap="square"/>
+                    <a:bodyPr/>
                     <a:lstStyle/>
                     <a:p>
                       <a:pPr algn="l"/>
@@ -4923,7 +5035,7 @@
                 </a:tc>
                 <a:tc>
                   <a:txBody>
-                    <a:bodyPr wrap="square"/>
+                    <a:bodyPr/>
                     <a:lstStyle/>
                     <a:p>
                       <a:pPr algn="l"/>
@@ -4946,7 +5058,7 @@
                 </a:tc>
                 <a:tc>
                   <a:txBody>
-                    <a:bodyPr wrap="square"/>
+                    <a:bodyPr/>
                     <a:lstStyle/>
                     <a:p>
                       <a:pPr algn="ctr"/>
@@ -4967,11 +5079,16 @@
                     </a:solidFill>
                   </a:tcPr>
                 </a:tc>
+                <a:extLst>
+                  <a:ext uri="{0D108BD9-81ED-4DB2-BD59-A6C34878D82A}">
+                    <a16:rowId xmlns:a16="http://schemas.microsoft.com/office/drawing/2014/main" val="10013"/>
+                  </a:ext>
+                </a:extLst>
               </a:tr>
               <a:tr h="350000">
                 <a:tc>
                   <a:txBody>
-                    <a:bodyPr wrap="square"/>
+                    <a:bodyPr/>
                     <a:lstStyle/>
                     <a:p>
                       <a:pPr algn="l"/>
@@ -4994,7 +5111,7 @@
                 </a:tc>
                 <a:tc>
                   <a:txBody>
-                    <a:bodyPr wrap="square"/>
+                    <a:bodyPr/>
                     <a:lstStyle/>
                     <a:p>
                       <a:pPr algn="l"/>
@@ -5017,7 +5134,7 @@
                 </a:tc>
                 <a:tc>
                   <a:txBody>
-                    <a:bodyPr wrap="square"/>
+                    <a:bodyPr/>
                     <a:lstStyle/>
                     <a:p>
                       <a:pPr algn="ctr"/>
@@ -5038,6 +5155,11 @@
                     </a:solidFill>
                   </a:tcPr>
                 </a:tc>
+                <a:extLst>
+                  <a:ext uri="{0D108BD9-81ED-4DB2-BD59-A6C34878D82A}">
+                    <a16:rowId xmlns:a16="http://schemas.microsoft.com/office/drawing/2014/main" val="10014"/>
+                  </a:ext>
+                </a:extLst>
               </a:tr>
             </a:tbl>
           </a:graphicData>
@@ -5052,7 +5174,7 @@
 </file>
 
 <file path=ppt/slides/slide4.xml><?xml version="1.0" encoding="utf-8"?>
-<p:sld xmlns:a="http://schemas.openxmlformats.org/drawingml/2006/main" xmlns:p="http://schemas.openxmlformats.org/presentationml/2006/main" xmlns:r="http://schemas.openxmlformats.org/officeDocument/2006/relationships">
+<p:sld xmlns:a="http://schemas.openxmlformats.org/drawingml/2006/main" xmlns:r="http://schemas.openxmlformats.org/officeDocument/2006/relationships" xmlns:p="http://schemas.openxmlformats.org/presentationml/2006/main">
   <p:cSld>
     <p:spTree>
       <p:nvGrpSpPr>
@@ -5060,7 +5182,14 @@
         <p:cNvGrpSpPr/>
         <p:nvPr/>
       </p:nvGrpSpPr>
-      <p:grpSpPr/>
+      <p:grpSpPr>
+        <a:xfrm>
+          <a:off x="0" y="0"/>
+          <a:ext cx="0" cy="0"/>
+          <a:chOff x="0" y="0"/>
+          <a:chExt cx="0" cy="0"/>
+        </a:xfrm>
+      </p:grpSpPr>
       <p:sp>
         <p:nvSpPr>
           <p:cNvPr id="2" name="Right Triangle 1"/>
@@ -5102,6 +5231,7 @@
           <a:lstStyle/>
           <a:p>
             <a:pPr algn="ctr"/>
+            <a:endParaRPr/>
           </a:p>
         </p:txBody>
       </p:sp>
@@ -5304,60 +5434,6 @@
           </a:p>
         </p:txBody>
       </p:sp>
-      <p:sp>
-        <p:nvSpPr>
-          <p:cNvPr id="7" name="Rounded Rectangle 6"/>
-          <p:cNvSpPr/>
-          <p:nvPr/>
-        </p:nvSpPr>
-        <p:spPr>
-          <a:xfrm>
-            <a:off x="700000" y="5600000"/>
-            <a:ext cx="10800000" cy="650000"/>
-          </a:xfrm>
-          <a:prstGeom prst="roundRect">
-            <a:avLst/>
-          </a:prstGeom>
-          <a:solidFill>
-            <a:srgbClr val="FFFFFF"/>
-          </a:solidFill>
-          <a:ln w="19050">
-            <a:solidFill>
-              <a:srgbClr val="1C3087"/>
-            </a:solidFill>
-          </a:ln>
-          <a:effectLst/>
-        </p:spPr>
-        <p:style>
-          <a:lnRef idx="1">
-            <a:schemeClr val="accent1"/>
-          </a:lnRef>
-          <a:fillRef idx="3">
-            <a:schemeClr val="accent1"/>
-          </a:fillRef>
-          <a:effectRef idx="2">
-            <a:schemeClr val="accent1"/>
-          </a:effectRef>
-          <a:fontRef idx="minor">
-            <a:schemeClr val="lt1"/>
-          </a:fontRef>
-        </p:style>
-        <p:txBody>
-          <a:bodyPr rtlCol="0" anchor="ctr" wrap="square" lIns="180000"/>
-          <a:lstStyle/>
-          <a:p>
-            <a:pPr algn="ctr"/>
-            <a:r>
-              <a:rPr sz="1400" b="1">
-                <a:solidFill>
-                  <a:srgbClr val="1C3087"/>
-                </a:solidFill>
-              </a:rPr>
-              <a:t>Modelo final: round8_distress_fix_scale083.csv</a:t>
-            </a:r>
-          </a:p>
-        </p:txBody>
-      </p:sp>
     </p:spTree>
   </p:cSld>
   <p:clrMapOvr>
@@ -5367,7 +5443,7 @@
 </file>
 
 <file path=ppt/slides/slide5.xml><?xml version="1.0" encoding="utf-8"?>
-<p:sld xmlns:a="http://schemas.openxmlformats.org/drawingml/2006/main" xmlns:p="http://schemas.openxmlformats.org/presentationml/2006/main" xmlns:r="http://schemas.openxmlformats.org/officeDocument/2006/relationships">
+<p:sld xmlns:a="http://schemas.openxmlformats.org/drawingml/2006/main" xmlns:r="http://schemas.openxmlformats.org/officeDocument/2006/relationships" xmlns:p="http://schemas.openxmlformats.org/presentationml/2006/main">
   <p:cSld>
     <p:spTree>
       <p:nvGrpSpPr>
@@ -5375,7 +5451,14 @@
         <p:cNvGrpSpPr/>
         <p:nvPr/>
       </p:nvGrpSpPr>
-      <p:grpSpPr/>
+      <p:grpSpPr>
+        <a:xfrm>
+          <a:off x="0" y="0"/>
+          <a:ext cx="0" cy="0"/>
+          <a:chOff x="0" y="0"/>
+          <a:chExt cx="0" cy="0"/>
+        </a:xfrm>
+      </p:grpSpPr>
       <p:sp>
         <p:nvSpPr>
           <p:cNvPr id="2" name="Right Triangle 1"/>
@@ -5384,7 +5467,7 @@
         </p:nvSpPr>
         <p:spPr>
           <a:xfrm>
-            <a:off x="186158" y="-198852"/>
+            <a:off x="-50000" y="0"/>
             <a:ext cx="1901656" cy="2273969"/>
           </a:xfrm>
           <a:prstGeom prst="rtTriangle">
@@ -5417,6 +5500,7 @@
           <a:lstStyle/>
           <a:p>
             <a:pPr algn="ctr"/>
+            <a:endParaRPr/>
           </a:p>
         </p:txBody>
       </p:sp>
@@ -5436,7 +5520,7 @@
         </p:blipFill>
         <p:spPr>
           <a:xfrm>
-            <a:off x="10145000" y="5550000"/>
+            <a:off x="10445496" y="62064"/>
             <a:ext cx="1746504" cy="1170432"/>
           </a:xfrm>
           <a:prstGeom prst="rect">
@@ -5567,13 +5651,265 @@
               </a:spcAft>
             </a:pPr>
             <a:r>
-              <a:rPr sz="1400">
+              <a:rPr sz="1400" dirty="0">
                 <a:solidFill>
                   <a:srgbClr val="222222"/>
                 </a:solidFill>
                 <a:latin typeface="Calibri"/>
               </a:rPr>
-              <a:t>Unico cambio respecto a Ronda 8: agregar 18 features semanticas extraidas de las descripciones con un LLM local (Ollama). Empeoro el modelo — y lo confirmamos con una comparacion controlada antes de descartarlo.</a:t>
+              <a:t>Unico </a:t>
+            </a:r>
+            <a:r>
+              <a:rPr sz="1400" dirty="0" err="1">
+                <a:solidFill>
+                  <a:srgbClr val="222222"/>
+                </a:solidFill>
+                <a:latin typeface="Calibri"/>
+              </a:rPr>
+              <a:t>cambio</a:t>
+            </a:r>
+            <a:r>
+              <a:rPr sz="1400" dirty="0">
+                <a:solidFill>
+                  <a:srgbClr val="222222"/>
+                </a:solidFill>
+                <a:latin typeface="Calibri"/>
+              </a:rPr>
+              <a:t> </a:t>
+            </a:r>
+            <a:r>
+              <a:rPr sz="1400" dirty="0" err="1">
+                <a:solidFill>
+                  <a:srgbClr val="222222"/>
+                </a:solidFill>
+                <a:latin typeface="Calibri"/>
+              </a:rPr>
+              <a:t>respecto</a:t>
+            </a:r>
+            <a:r>
+              <a:rPr sz="1400" dirty="0">
+                <a:solidFill>
+                  <a:srgbClr val="222222"/>
+                </a:solidFill>
+                <a:latin typeface="Calibri"/>
+              </a:rPr>
+              <a:t> a Ronda 8: </a:t>
+            </a:r>
+            <a:r>
+              <a:rPr sz="1400" dirty="0" err="1">
+                <a:solidFill>
+                  <a:srgbClr val="222222"/>
+                </a:solidFill>
+                <a:latin typeface="Calibri"/>
+              </a:rPr>
+              <a:t>agregar</a:t>
+            </a:r>
+            <a:r>
+              <a:rPr sz="1400" dirty="0">
+                <a:solidFill>
+                  <a:srgbClr val="222222"/>
+                </a:solidFill>
+                <a:latin typeface="Calibri"/>
+              </a:rPr>
+              <a:t> 18 features </a:t>
+            </a:r>
+            <a:r>
+              <a:rPr sz="1400" dirty="0" err="1">
+                <a:solidFill>
+                  <a:srgbClr val="222222"/>
+                </a:solidFill>
+                <a:latin typeface="Calibri"/>
+              </a:rPr>
+              <a:t>semanticas</a:t>
+            </a:r>
+            <a:r>
+              <a:rPr sz="1400" dirty="0">
+                <a:solidFill>
+                  <a:srgbClr val="222222"/>
+                </a:solidFill>
+                <a:latin typeface="Calibri"/>
+              </a:rPr>
+              <a:t> </a:t>
+            </a:r>
+            <a:r>
+              <a:rPr sz="1400" dirty="0" err="1">
+                <a:solidFill>
+                  <a:srgbClr val="222222"/>
+                </a:solidFill>
+                <a:latin typeface="Calibri"/>
+              </a:rPr>
+              <a:t>extraidas</a:t>
+            </a:r>
+            <a:r>
+              <a:rPr sz="1400" dirty="0">
+                <a:solidFill>
+                  <a:srgbClr val="222222"/>
+                </a:solidFill>
+                <a:latin typeface="Calibri"/>
+              </a:rPr>
+              <a:t> de las </a:t>
+            </a:r>
+            <a:r>
+              <a:rPr sz="1400" dirty="0" err="1">
+                <a:solidFill>
+                  <a:srgbClr val="222222"/>
+                </a:solidFill>
+                <a:latin typeface="Calibri"/>
+              </a:rPr>
+              <a:t>descripciones</a:t>
+            </a:r>
+            <a:r>
+              <a:rPr sz="1400" dirty="0">
+                <a:solidFill>
+                  <a:srgbClr val="222222"/>
+                </a:solidFill>
+                <a:latin typeface="Calibri"/>
+              </a:rPr>
+              <a:t> con un LLM local (</a:t>
+            </a:r>
+            <a:r>
+              <a:rPr sz="1400" dirty="0" err="1">
+                <a:solidFill>
+                  <a:srgbClr val="222222"/>
+                </a:solidFill>
+                <a:latin typeface="Calibri"/>
+              </a:rPr>
+              <a:t>Ollama</a:t>
+            </a:r>
+            <a:r>
+              <a:rPr sz="1400" dirty="0">
+                <a:solidFill>
+                  <a:srgbClr val="222222"/>
+                </a:solidFill>
+                <a:latin typeface="Calibri"/>
+              </a:rPr>
+              <a:t>). </a:t>
+            </a:r>
+            <a:r>
+              <a:rPr sz="1400" dirty="0" err="1">
+                <a:solidFill>
+                  <a:srgbClr val="222222"/>
+                </a:solidFill>
+                <a:latin typeface="Calibri"/>
+              </a:rPr>
+              <a:t>Empeoro</a:t>
+            </a:r>
+            <a:r>
+              <a:rPr sz="1400" dirty="0">
+                <a:solidFill>
+                  <a:srgbClr val="222222"/>
+                </a:solidFill>
+                <a:latin typeface="Calibri"/>
+              </a:rPr>
+              <a:t> el </a:t>
+            </a:r>
+            <a:r>
+              <a:rPr sz="1400" dirty="0" err="1">
+                <a:solidFill>
+                  <a:srgbClr val="222222"/>
+                </a:solidFill>
+                <a:latin typeface="Calibri"/>
+              </a:rPr>
+              <a:t>modelo</a:t>
+            </a:r>
+            <a:r>
+              <a:rPr sz="1400" dirty="0">
+                <a:solidFill>
+                  <a:srgbClr val="222222"/>
+                </a:solidFill>
+                <a:latin typeface="Calibri"/>
+              </a:rPr>
+              <a:t> — y lo </a:t>
+            </a:r>
+            <a:r>
+              <a:rPr sz="1400" dirty="0" err="1">
+                <a:solidFill>
+                  <a:srgbClr val="222222"/>
+                </a:solidFill>
+                <a:latin typeface="Calibri"/>
+              </a:rPr>
+              <a:t>confirmamos</a:t>
+            </a:r>
+            <a:r>
+              <a:rPr sz="1400" dirty="0">
+                <a:solidFill>
+                  <a:srgbClr val="222222"/>
+                </a:solidFill>
+                <a:latin typeface="Calibri"/>
+              </a:rPr>
+              <a:t> con </a:t>
+            </a:r>
+            <a:r>
+              <a:rPr sz="1400" dirty="0" err="1">
+                <a:solidFill>
+                  <a:srgbClr val="222222"/>
+                </a:solidFill>
+                <a:latin typeface="Calibri"/>
+              </a:rPr>
+              <a:t>una</a:t>
+            </a:r>
+            <a:r>
+              <a:rPr sz="1400" dirty="0">
+                <a:solidFill>
+                  <a:srgbClr val="222222"/>
+                </a:solidFill>
+                <a:latin typeface="Calibri"/>
+              </a:rPr>
+              <a:t> </a:t>
+            </a:r>
+            <a:r>
+              <a:rPr sz="1400" dirty="0" err="1">
+                <a:solidFill>
+                  <a:srgbClr val="222222"/>
+                </a:solidFill>
+                <a:latin typeface="Calibri"/>
+              </a:rPr>
+              <a:t>comparacion</a:t>
+            </a:r>
+            <a:r>
+              <a:rPr sz="1400" dirty="0">
+                <a:solidFill>
+                  <a:srgbClr val="222222"/>
+                </a:solidFill>
+                <a:latin typeface="Calibri"/>
+              </a:rPr>
+              <a:t> </a:t>
+            </a:r>
+            <a:r>
+              <a:rPr sz="1400" dirty="0" err="1">
+                <a:solidFill>
+                  <a:srgbClr val="222222"/>
+                </a:solidFill>
+                <a:latin typeface="Calibri"/>
+              </a:rPr>
+              <a:t>controlada</a:t>
+            </a:r>
+            <a:r>
+              <a:rPr sz="1400" dirty="0">
+                <a:solidFill>
+                  <a:srgbClr val="222222"/>
+                </a:solidFill>
+                <a:latin typeface="Calibri"/>
+              </a:rPr>
+              <a:t> antes de </a:t>
+            </a:r>
+            <a:r>
+              <a:rPr sz="1400" dirty="0" err="1">
+                <a:solidFill>
+                  <a:srgbClr val="222222"/>
+                </a:solidFill>
+                <a:latin typeface="Calibri"/>
+              </a:rPr>
+              <a:t>descartarlo</a:t>
+            </a:r>
+            <a:r>
+              <a:rPr sz="1400" dirty="0">
+                <a:solidFill>
+                  <a:srgbClr val="222222"/>
+                </a:solidFill>
+                <a:latin typeface="Calibri"/>
+              </a:rPr>
+              <a:t>.</a:t>
             </a:r>
           </a:p>
         </p:txBody>
@@ -5587,7 +5923,7 @@
 </file>
 
 <file path=ppt/slides/slide6.xml><?xml version="1.0" encoding="utf-8"?>
-<p:sld xmlns:a="http://schemas.openxmlformats.org/drawingml/2006/main" xmlns:p="http://schemas.openxmlformats.org/presentationml/2006/main" xmlns:r="http://schemas.openxmlformats.org/officeDocument/2006/relationships">
+<p:sld xmlns:a="http://schemas.openxmlformats.org/drawingml/2006/main" xmlns:r="http://schemas.openxmlformats.org/officeDocument/2006/relationships" xmlns:p="http://schemas.openxmlformats.org/presentationml/2006/main">
   <p:cSld>
     <p:spTree>
       <p:nvGrpSpPr>
@@ -5595,7 +5931,14 @@
         <p:cNvGrpSpPr/>
         <p:nvPr/>
       </p:nvGrpSpPr>
-      <p:grpSpPr/>
+      <p:grpSpPr>
+        <a:xfrm>
+          <a:off x="0" y="0"/>
+          <a:ext cx="0" cy="0"/>
+          <a:chOff x="0" y="0"/>
+          <a:chExt cx="0" cy="0"/>
+        </a:xfrm>
+      </p:grpSpPr>
       <p:sp>
         <p:nvSpPr>
           <p:cNvPr id="2" name="Right Triangle 1"/>
@@ -5637,6 +5980,7 @@
           <a:lstStyle/>
           <a:p>
             <a:pPr algn="ctr"/>
+            <a:endParaRPr/>
           </a:p>
         </p:txBody>
       </p:sp>
@@ -5825,7 +6169,7 @@
 </file>
 
 <file path=ppt/slides/slide7.xml><?xml version="1.0" encoding="utf-8"?>
-<p:sld xmlns:a="http://schemas.openxmlformats.org/drawingml/2006/main" xmlns:p="http://schemas.openxmlformats.org/presentationml/2006/main" xmlns:r="http://schemas.openxmlformats.org/officeDocument/2006/relationships">
+<p:sld xmlns:a="http://schemas.openxmlformats.org/drawingml/2006/main" xmlns:r="http://schemas.openxmlformats.org/officeDocument/2006/relationships" xmlns:p="http://schemas.openxmlformats.org/presentationml/2006/main">
   <p:cSld>
     <p:spTree>
       <p:nvGrpSpPr>
@@ -5833,7 +6177,14 @@
         <p:cNvGrpSpPr/>
         <p:nvPr/>
       </p:nvGrpSpPr>
-      <p:grpSpPr/>
+      <p:grpSpPr>
+        <a:xfrm>
+          <a:off x="0" y="0"/>
+          <a:ext cx="0" cy="0"/>
+          <a:chOff x="0" y="0"/>
+          <a:chExt cx="0" cy="0"/>
+        </a:xfrm>
+      </p:grpSpPr>
       <p:sp>
         <p:nvSpPr>
           <p:cNvPr id="2" name="Right Triangle 1"/>
@@ -5842,7 +6193,7 @@
         </p:nvSpPr>
         <p:spPr>
           <a:xfrm>
-            <a:off x="186158" y="-198852"/>
+            <a:off x="11492000" y="-923969"/>
             <a:ext cx="1901656" cy="2273969"/>
           </a:xfrm>
           <a:prstGeom prst="rtTriangle">
@@ -5875,6 +6226,7 @@
           <a:lstStyle/>
           <a:p>
             <a:pPr algn="ctr"/>
+            <a:endParaRPr/>
           </a:p>
         </p:txBody>
       </p:sp>
@@ -6031,15 +6383,39 @@
                 <a:tableStyleId>{5C22544A-7EE6-4342-B048-85BDC9FD1C3A}</a:tableStyleId>
               </a:tblPr>
               <a:tblGrid>
-                <a:gridCol w="2350000"/>
-                <a:gridCol w="2350000"/>
-                <a:gridCol w="2350000"/>
-                <a:gridCol w="2350000"/>
+                <a:gridCol w="2350000">
+                  <a:extLst>
+                    <a:ext uri="{9D8B030D-6E8A-4147-A177-3AD203B41FA5}">
+                      <a16:colId xmlns:a16="http://schemas.microsoft.com/office/drawing/2014/main" val="20000"/>
+                    </a:ext>
+                  </a:extLst>
+                </a:gridCol>
+                <a:gridCol w="2350000">
+                  <a:extLst>
+                    <a:ext uri="{9D8B030D-6E8A-4147-A177-3AD203B41FA5}">
+                      <a16:colId xmlns:a16="http://schemas.microsoft.com/office/drawing/2014/main" val="20001"/>
+                    </a:ext>
+                  </a:extLst>
+                </a:gridCol>
+                <a:gridCol w="2350000">
+                  <a:extLst>
+                    <a:ext uri="{9D8B030D-6E8A-4147-A177-3AD203B41FA5}">
+                      <a16:colId xmlns:a16="http://schemas.microsoft.com/office/drawing/2014/main" val="20002"/>
+                    </a:ext>
+                  </a:extLst>
+                </a:gridCol>
+                <a:gridCol w="2350000">
+                  <a:extLst>
+                    <a:ext uri="{9D8B030D-6E8A-4147-A177-3AD203B41FA5}">
+                      <a16:colId xmlns:a16="http://schemas.microsoft.com/office/drawing/2014/main" val="20003"/>
+                    </a:ext>
+                  </a:extLst>
+                </a:gridCol>
               </a:tblGrid>
               <a:tr h="400000">
                 <a:tc>
                   <a:txBody>
-                    <a:bodyPr wrap="square"/>
+                    <a:bodyPr/>
                     <a:lstStyle/>
                     <a:p>
                       <a:pPr algn="ctr"/>
@@ -6062,7 +6438,7 @@
                 </a:tc>
                 <a:tc>
                   <a:txBody>
-                    <a:bodyPr wrap="square"/>
+                    <a:bodyPr/>
                     <a:lstStyle/>
                     <a:p>
                       <a:pPr algn="ctr"/>
@@ -6085,7 +6461,7 @@
                 </a:tc>
                 <a:tc>
                   <a:txBody>
-                    <a:bodyPr wrap="square"/>
+                    <a:bodyPr/>
                     <a:lstStyle/>
                     <a:p>
                       <a:pPr algn="ctr"/>
@@ -6108,7 +6484,7 @@
                 </a:tc>
                 <a:tc>
                   <a:txBody>
-                    <a:bodyPr wrap="square"/>
+                    <a:bodyPr/>
                     <a:lstStyle/>
                     <a:p>
                       <a:pPr algn="ctr"/>
@@ -6129,11 +6505,16 @@
                     </a:solidFill>
                   </a:tcPr>
                 </a:tc>
+                <a:extLst>
+                  <a:ext uri="{0D108BD9-81ED-4DB2-BD59-A6C34878D82A}">
+                    <a16:rowId xmlns:a16="http://schemas.microsoft.com/office/drawing/2014/main" val="10000"/>
+                  </a:ext>
+                </a:extLst>
               </a:tr>
               <a:tr h="400000">
                 <a:tc>
                   <a:txBody>
-                    <a:bodyPr wrap="square"/>
+                    <a:bodyPr/>
                     <a:lstStyle/>
                     <a:p>
                       <a:pPr algn="ctr"/>
@@ -6156,7 +6537,7 @@
                 </a:tc>
                 <a:tc>
                   <a:txBody>
-                    <a:bodyPr wrap="square"/>
+                    <a:bodyPr/>
                     <a:lstStyle/>
                     <a:p>
                       <a:pPr algn="ctr"/>
@@ -6179,7 +6560,7 @@
                 </a:tc>
                 <a:tc>
                   <a:txBody>
-                    <a:bodyPr wrap="square"/>
+                    <a:bodyPr/>
                     <a:lstStyle/>
                     <a:p>
                       <a:pPr algn="ctr"/>
@@ -6202,7 +6583,7 @@
                 </a:tc>
                 <a:tc>
                   <a:txBody>
-                    <a:bodyPr wrap="square"/>
+                    <a:bodyPr/>
                     <a:lstStyle/>
                     <a:p>
                       <a:pPr algn="ctr"/>
@@ -6223,11 +6604,16 @@
                     </a:solidFill>
                   </a:tcPr>
                 </a:tc>
+                <a:extLst>
+                  <a:ext uri="{0D108BD9-81ED-4DB2-BD59-A6C34878D82A}">
+                    <a16:rowId xmlns:a16="http://schemas.microsoft.com/office/drawing/2014/main" val="10001"/>
+                  </a:ext>
+                </a:extLst>
               </a:tr>
               <a:tr h="400000">
                 <a:tc>
                   <a:txBody>
-                    <a:bodyPr wrap="square"/>
+                    <a:bodyPr/>
                     <a:lstStyle/>
                     <a:p>
                       <a:pPr algn="ctr"/>
@@ -6250,7 +6636,7 @@
                 </a:tc>
                 <a:tc>
                   <a:txBody>
-                    <a:bodyPr wrap="square"/>
+                    <a:bodyPr/>
                     <a:lstStyle/>
                     <a:p>
                       <a:pPr algn="ctr"/>
@@ -6273,7 +6659,7 @@
                 </a:tc>
                 <a:tc>
                   <a:txBody>
-                    <a:bodyPr wrap="square"/>
+                    <a:bodyPr/>
                     <a:lstStyle/>
                     <a:p>
                       <a:pPr algn="ctr"/>
@@ -6296,7 +6682,7 @@
                 </a:tc>
                 <a:tc>
                   <a:txBody>
-                    <a:bodyPr wrap="square"/>
+                    <a:bodyPr/>
                     <a:lstStyle/>
                     <a:p>
                       <a:pPr algn="ctr"/>
@@ -6317,11 +6703,16 @@
                     </a:solidFill>
                   </a:tcPr>
                 </a:tc>
+                <a:extLst>
+                  <a:ext uri="{0D108BD9-81ED-4DB2-BD59-A6C34878D82A}">
+                    <a16:rowId xmlns:a16="http://schemas.microsoft.com/office/drawing/2014/main" val="10002"/>
+                  </a:ext>
+                </a:extLst>
               </a:tr>
               <a:tr h="400000">
                 <a:tc>
                   <a:txBody>
-                    <a:bodyPr wrap="square"/>
+                    <a:bodyPr/>
                     <a:lstStyle/>
                     <a:p>
                       <a:pPr algn="ctr"/>
@@ -6344,7 +6735,7 @@
                 </a:tc>
                 <a:tc>
                   <a:txBody>
-                    <a:bodyPr wrap="square"/>
+                    <a:bodyPr/>
                     <a:lstStyle/>
                     <a:p>
                       <a:pPr algn="ctr"/>
@@ -6367,7 +6758,7 @@
                 </a:tc>
                 <a:tc>
                   <a:txBody>
-                    <a:bodyPr wrap="square"/>
+                    <a:bodyPr/>
                     <a:lstStyle/>
                     <a:p>
                       <a:pPr algn="ctr"/>
@@ -6390,7 +6781,7 @@
                 </a:tc>
                 <a:tc>
                   <a:txBody>
-                    <a:bodyPr wrap="square"/>
+                    <a:bodyPr/>
                     <a:lstStyle/>
                     <a:p>
                       <a:pPr algn="ctr"/>
@@ -6411,6 +6802,11 @@
                     </a:solidFill>
                   </a:tcPr>
                 </a:tc>
+                <a:extLst>
+                  <a:ext uri="{0D108BD9-81ED-4DB2-BD59-A6C34878D82A}">
+                    <a16:rowId xmlns:a16="http://schemas.microsoft.com/office/drawing/2014/main" val="10003"/>
+                  </a:ext>
+                </a:extLst>
               </a:tr>
             </a:tbl>
           </a:graphicData>
@@ -6455,7 +6851,7 @@
           </a:fontRef>
         </p:style>
         <p:txBody>
-          <a:bodyPr rtlCol="0" anchor="ctr" wrap="square" lIns="180000"/>
+          <a:bodyPr wrap="square" lIns="180000" rtlCol="0" anchor="ctr"/>
           <a:lstStyle/>
           <a:p>
             <a:pPr algn="ctr"/>
@@ -6521,7 +6917,7 @@
 </file>
 
 <file path=ppt/slides/slide8.xml><?xml version="1.0" encoding="utf-8"?>
-<p:sld xmlns:a="http://schemas.openxmlformats.org/drawingml/2006/main" xmlns:p="http://schemas.openxmlformats.org/presentationml/2006/main" xmlns:r="http://schemas.openxmlformats.org/officeDocument/2006/relationships">
+<p:sld xmlns:a="http://schemas.openxmlformats.org/drawingml/2006/main" xmlns:r="http://schemas.openxmlformats.org/officeDocument/2006/relationships" xmlns:p="http://schemas.openxmlformats.org/presentationml/2006/main">
   <p:cSld>
     <p:spTree>
       <p:nvGrpSpPr>
@@ -6529,7 +6925,14 @@
         <p:cNvGrpSpPr/>
         <p:nvPr/>
       </p:nvGrpSpPr>
-      <p:grpSpPr/>
+      <p:grpSpPr>
+        <a:xfrm>
+          <a:off x="0" y="0"/>
+          <a:ext cx="0" cy="0"/>
+          <a:chOff x="0" y="0"/>
+          <a:chExt cx="0" cy="0"/>
+        </a:xfrm>
+      </p:grpSpPr>
       <p:sp>
         <p:nvSpPr>
           <p:cNvPr id="2" name="Right Triangle 1"/>
@@ -6571,6 +6974,7 @@
           <a:lstStyle/>
           <a:p>
             <a:pPr algn="ctr"/>
+            <a:endParaRPr/>
           </a:p>
         </p:txBody>
       </p:sp>
@@ -6727,15 +7131,39 @@
                 <a:tableStyleId>{5C22544A-7EE6-4342-B048-85BDC9FD1C3A}</a:tableStyleId>
               </a:tblPr>
               <a:tblGrid>
-                <a:gridCol w="2250000"/>
-                <a:gridCol w="2250000"/>
-                <a:gridCol w="2250000"/>
-                <a:gridCol w="2250000"/>
+                <a:gridCol w="2250000">
+                  <a:extLst>
+                    <a:ext uri="{9D8B030D-6E8A-4147-A177-3AD203B41FA5}">
+                      <a16:colId xmlns:a16="http://schemas.microsoft.com/office/drawing/2014/main" val="20000"/>
+                    </a:ext>
+                  </a:extLst>
+                </a:gridCol>
+                <a:gridCol w="2250000">
+                  <a:extLst>
+                    <a:ext uri="{9D8B030D-6E8A-4147-A177-3AD203B41FA5}">
+                      <a16:colId xmlns:a16="http://schemas.microsoft.com/office/drawing/2014/main" val="20001"/>
+                    </a:ext>
+                  </a:extLst>
+                </a:gridCol>
+                <a:gridCol w="2250000">
+                  <a:extLst>
+                    <a:ext uri="{9D8B030D-6E8A-4147-A177-3AD203B41FA5}">
+                      <a16:colId xmlns:a16="http://schemas.microsoft.com/office/drawing/2014/main" val="20002"/>
+                    </a:ext>
+                  </a:extLst>
+                </a:gridCol>
+                <a:gridCol w="2250000">
+                  <a:extLst>
+                    <a:ext uri="{9D8B030D-6E8A-4147-A177-3AD203B41FA5}">
+                      <a16:colId xmlns:a16="http://schemas.microsoft.com/office/drawing/2014/main" val="20003"/>
+                    </a:ext>
+                  </a:extLst>
+                </a:gridCol>
               </a:tblGrid>
               <a:tr h="375000">
                 <a:tc>
                   <a:txBody>
-                    <a:bodyPr wrap="square"/>
+                    <a:bodyPr/>
                     <a:lstStyle/>
                     <a:p>
                       <a:pPr algn="ctr"/>
@@ -6758,7 +7186,7 @@
                 </a:tc>
                 <a:tc>
                   <a:txBody>
-                    <a:bodyPr wrap="square"/>
+                    <a:bodyPr/>
                     <a:lstStyle/>
                     <a:p>
                       <a:pPr algn="ctr"/>
@@ -6781,7 +7209,7 @@
                 </a:tc>
                 <a:tc>
                   <a:txBody>
-                    <a:bodyPr wrap="square"/>
+                    <a:bodyPr/>
                     <a:lstStyle/>
                     <a:p>
                       <a:pPr algn="ctr"/>
@@ -6804,7 +7232,7 @@
                 </a:tc>
                 <a:tc>
                   <a:txBody>
-                    <a:bodyPr wrap="square"/>
+                    <a:bodyPr/>
                     <a:lstStyle/>
                     <a:p>
                       <a:pPr algn="ctr"/>
@@ -6825,11 +7253,16 @@
                     </a:solidFill>
                   </a:tcPr>
                 </a:tc>
+                <a:extLst>
+                  <a:ext uri="{0D108BD9-81ED-4DB2-BD59-A6C34878D82A}">
+                    <a16:rowId xmlns:a16="http://schemas.microsoft.com/office/drawing/2014/main" val="10000"/>
+                  </a:ext>
+                </a:extLst>
               </a:tr>
               <a:tr h="375000">
                 <a:tc>
                   <a:txBody>
-                    <a:bodyPr wrap="square"/>
+                    <a:bodyPr/>
                     <a:lstStyle/>
                     <a:p>
                       <a:pPr algn="ctr"/>
@@ -6852,7 +7285,7 @@
                 </a:tc>
                 <a:tc>
                   <a:txBody>
-                    <a:bodyPr wrap="square"/>
+                    <a:bodyPr/>
                     <a:lstStyle/>
                     <a:p>
                       <a:pPr algn="ctr"/>
@@ -6875,7 +7308,7 @@
                 </a:tc>
                 <a:tc>
                   <a:txBody>
-                    <a:bodyPr wrap="square"/>
+                    <a:bodyPr/>
                     <a:lstStyle/>
                     <a:p>
                       <a:pPr algn="ctr"/>
@@ -6898,7 +7331,7 @@
                 </a:tc>
                 <a:tc>
                   <a:txBody>
-                    <a:bodyPr wrap="square"/>
+                    <a:bodyPr/>
                     <a:lstStyle/>
                     <a:p>
                       <a:pPr algn="ctr"/>
@@ -6919,11 +7352,16 @@
                     </a:solidFill>
                   </a:tcPr>
                 </a:tc>
+                <a:extLst>
+                  <a:ext uri="{0D108BD9-81ED-4DB2-BD59-A6C34878D82A}">
+                    <a16:rowId xmlns:a16="http://schemas.microsoft.com/office/drawing/2014/main" val="10001"/>
+                  </a:ext>
+                </a:extLst>
               </a:tr>
               <a:tr h="375000">
                 <a:tc>
                   <a:txBody>
-                    <a:bodyPr wrap="square"/>
+                    <a:bodyPr/>
                     <a:lstStyle/>
                     <a:p>
                       <a:pPr algn="ctr"/>
@@ -6946,7 +7384,7 @@
                 </a:tc>
                 <a:tc>
                   <a:txBody>
-                    <a:bodyPr wrap="square"/>
+                    <a:bodyPr/>
                     <a:lstStyle/>
                     <a:p>
                       <a:pPr algn="ctr"/>
@@ -6969,7 +7407,7 @@
                 </a:tc>
                 <a:tc>
                   <a:txBody>
-                    <a:bodyPr wrap="square"/>
+                    <a:bodyPr/>
                     <a:lstStyle/>
                     <a:p>
                       <a:pPr algn="ctr"/>
@@ -6992,7 +7430,7 @@
                 </a:tc>
                 <a:tc>
                   <a:txBody>
-                    <a:bodyPr wrap="square"/>
+                    <a:bodyPr/>
                     <a:lstStyle/>
                     <a:p>
                       <a:pPr algn="ctr"/>
@@ -7013,11 +7451,16 @@
                     </a:solidFill>
                   </a:tcPr>
                 </a:tc>
+                <a:extLst>
+                  <a:ext uri="{0D108BD9-81ED-4DB2-BD59-A6C34878D82A}">
+                    <a16:rowId xmlns:a16="http://schemas.microsoft.com/office/drawing/2014/main" val="10002"/>
+                  </a:ext>
+                </a:extLst>
               </a:tr>
               <a:tr h="375000">
                 <a:tc>
                   <a:txBody>
-                    <a:bodyPr wrap="square"/>
+                    <a:bodyPr/>
                     <a:lstStyle/>
                     <a:p>
                       <a:pPr algn="ctr"/>
@@ -7040,7 +7483,7 @@
                 </a:tc>
                 <a:tc>
                   <a:txBody>
-                    <a:bodyPr wrap="square"/>
+                    <a:bodyPr/>
                     <a:lstStyle/>
                     <a:p>
                       <a:pPr algn="ctr"/>
@@ -7063,7 +7506,7 @@
                 </a:tc>
                 <a:tc>
                   <a:txBody>
-                    <a:bodyPr wrap="square"/>
+                    <a:bodyPr/>
                     <a:lstStyle/>
                     <a:p>
                       <a:pPr algn="ctr"/>
@@ -7086,7 +7529,7 @@
                 </a:tc>
                 <a:tc>
                   <a:txBody>
-                    <a:bodyPr wrap="square"/>
+                    <a:bodyPr/>
                     <a:lstStyle/>
                     <a:p>
                       <a:pPr algn="ctr"/>
@@ -7107,6 +7550,11 @@
                     </a:solidFill>
                   </a:tcPr>
                 </a:tc>
+                <a:extLst>
+                  <a:ext uri="{0D108BD9-81ED-4DB2-BD59-A6C34878D82A}">
+                    <a16:rowId xmlns:a16="http://schemas.microsoft.com/office/drawing/2014/main" val="10003"/>
+                  </a:ext>
+                </a:extLst>
               </a:tr>
             </a:tbl>
           </a:graphicData>
@@ -7151,7 +7599,7 @@
           </a:fontRef>
         </p:style>
         <p:txBody>
-          <a:bodyPr rtlCol="0" anchor="ctr" wrap="square" lIns="180000"/>
+          <a:bodyPr wrap="square" lIns="180000" rtlCol="0" anchor="ctr"/>
           <a:lstStyle/>
           <a:p>
             <a:pPr algn="ctr"/>
@@ -7217,7 +7665,7 @@
 </file>
 
 <file path=ppt/slides/slide9.xml><?xml version="1.0" encoding="utf-8"?>
-<p:sld xmlns:a="http://schemas.openxmlformats.org/drawingml/2006/main" xmlns:p="http://schemas.openxmlformats.org/presentationml/2006/main" xmlns:r="http://schemas.openxmlformats.org/officeDocument/2006/relationships">
+<p:sld xmlns:a="http://schemas.openxmlformats.org/drawingml/2006/main" xmlns:r="http://schemas.openxmlformats.org/officeDocument/2006/relationships" xmlns:p="http://schemas.openxmlformats.org/presentationml/2006/main">
   <p:cSld>
     <p:spTree>
       <p:nvGrpSpPr>
@@ -7225,7 +7673,14 @@
         <p:cNvGrpSpPr/>
         <p:nvPr/>
       </p:nvGrpSpPr>
-      <p:grpSpPr/>
+      <p:grpSpPr>
+        <a:xfrm>
+          <a:off x="0" y="0"/>
+          <a:ext cx="0" cy="0"/>
+          <a:chOff x="0" y="0"/>
+          <a:chExt cx="0" cy="0"/>
+        </a:xfrm>
+      </p:grpSpPr>
       <p:sp>
         <p:nvSpPr>
           <p:cNvPr id="2" name="Right Triangle 1"/>
@@ -7267,6 +7722,7 @@
           <a:lstStyle/>
           <a:p>
             <a:pPr algn="ctr"/>
+            <a:endParaRPr/>
           </a:p>
         </p:txBody>
       </p:sp>
@@ -7401,7 +7857,7 @@
           </a:fontRef>
         </p:style>
         <p:txBody>
-          <a:bodyPr rtlCol="0" anchor="ctr" wrap="square" lIns="180000"/>
+          <a:bodyPr wrap="square" lIns="180000" rtlCol="0" anchor="ctr"/>
           <a:lstStyle/>
           <a:p>
             <a:pPr algn="ctr"/>

</xml_diff>